<commit_message>
Remove key findings/SCAL results slides; convert all durations to min/hrs
- Drop 'Duyong Deep 1 Key SCAL Results' and 'Pegaga-2 Sample Properties'
  detail slides — now 25 slides total (was 27)
- All duration values converted from raw seconds to min (< 1 hr) or
  hrs (>= 1 hr) throughout tables and footer text
- Benchmark comparison updated with formatted durations

https://claude.ai/code/session_016iSdMZ2YZ9rCiw11HkYQ7S
</commit_message>
<xml_diff>
--- a/[24] 26 Feb 2026_ver05.pptx
+++ b/[24] 26 Feb 2026_ver05.pptx
@@ -33,8 +33,6 @@
     <p:sldId id="492" r:id="rId29"/>
     <p:sldId id="493" r:id="rId30"/>
     <p:sldId id="494" r:id="rId31"/>
-    <p:sldId id="495" r:id="rId32"/>
-    <p:sldId id="496" r:id="rId33"/>
   </p:sldIdLst>
   <p:sldSz cx="10693400" cy="7556500"/>
   <p:notesSz cx="10693400" cy="7556500"/>
@@ -14282,7 +14280,7 @@
                   <a:srgbClr val="595959"/>
                 </a:solidFill>
               </a:rPr>
-              <a:t>Document: SPECIAL CORE ANALYSIS OF ROTARY SIDEWALL CORES (PETRONAS CARIGALI / UZMA ENGINEERING)  |  38 pages extracted</a:t>
+              <a:t>Document: SPECIAL CORE ANALYSIS OF ROTARY SIDEWALL CORES  (PETRONAS CARIGALI / UZMA ENGINEERING)  |  38 pages extracted</a:t>
             </a:r>
           </a:p>
         </p:txBody>
@@ -14297,7 +14295,7 @@
         </p:nvGraphicFramePr>
         <p:xfrm>
           <a:off x="350000" y="920000"/>
-          <a:ext cx="9993400" cy="6436500"/>
+          <a:ext cx="9993400" cy="6416500"/>
         </p:xfrm>
         <a:graphic>
           <a:graphicData uri="http://schemas.openxmlformats.org/drawingml/2006/table">
@@ -14306,12 +14304,12 @@
                 <a:tableStyleId>{5C22544A-7EE6-4342-B048-85BDC9FD1C3A}</a:tableStyleId>
               </a:tblPr>
               <a:tblGrid>
-                <a:gridCol w="999340"/>
-                <a:gridCol w="1598944"/>
+                <a:gridCol w="799472"/>
+                <a:gridCol w="1399076"/>
                 <a:gridCol w="1199208"/>
-                <a:gridCol w="6195908"/>
+                <a:gridCol w="6595644"/>
               </a:tblGrid>
-              <a:tr h="257460">
+              <a:tr h="256660">
                 <a:tc>
                   <a:txBody>
                     <a:bodyPr wrap="square"/>
@@ -14348,7 +14346,7 @@
                           </a:solidFill>
                           <a:latin typeface="Calibri"/>
                         </a:rPr>
-                        <a:t>Duration (s)</a:t>
+                        <a:t>Duration</a:t>
                       </a:r>
                     </a:p>
                   </a:txBody>
@@ -14405,7 +14403,7 @@
                   </a:tcPr>
                 </a:tc>
               </a:tr>
-              <a:tr h="257460">
+              <a:tr h="256660">
                 <a:tc>
                   <a:txBody>
                     <a:bodyPr wrap="square"/>
@@ -14442,7 +14440,7 @@
                           </a:solidFill>
                           <a:latin typeface="Calibri"/>
                         </a:rPr>
-                        <a:t>293.8</a:t>
+                        <a:t>4.9 min</a:t>
                       </a:r>
                     </a:p>
                   </a:txBody>
@@ -14499,7 +14497,7 @@
                   </a:tcPr>
                 </a:tc>
               </a:tr>
-              <a:tr h="257460">
+              <a:tr h="256660">
                 <a:tc>
                   <a:txBody>
                     <a:bodyPr wrap="square"/>
@@ -14536,7 +14534,7 @@
                           </a:solidFill>
                           <a:latin typeface="Calibri"/>
                         </a:rPr>
-                        <a:t>615.7</a:t>
+                        <a:t>10.3 min</a:t>
                       </a:r>
                     </a:p>
                   </a:txBody>
@@ -14593,7 +14591,7 @@
                   </a:tcPr>
                 </a:tc>
               </a:tr>
-              <a:tr h="257460">
+              <a:tr h="256660">
                 <a:tc>
                   <a:txBody>
                     <a:bodyPr wrap="square"/>
@@ -14630,7 +14628,7 @@
                           </a:solidFill>
                           <a:latin typeface="Calibri"/>
                         </a:rPr>
-                        <a:t>1,147.7</a:t>
+                        <a:t>19.1 min</a:t>
                       </a:r>
                     </a:p>
                   </a:txBody>
@@ -14687,7 +14685,7 @@
                   </a:tcPr>
                 </a:tc>
               </a:tr>
-              <a:tr h="257460">
+              <a:tr h="256660">
                 <a:tc>
                   <a:txBody>
                     <a:bodyPr wrap="square"/>
@@ -14724,7 +14722,7 @@
                           </a:solidFill>
                           <a:latin typeface="Calibri"/>
                         </a:rPr>
-                        <a:t>1,587.9</a:t>
+                        <a:t>26.5 min</a:t>
                       </a:r>
                     </a:p>
                   </a:txBody>
@@ -14781,7 +14779,7 @@
                   </a:tcPr>
                 </a:tc>
               </a:tr>
-              <a:tr h="257460">
+              <a:tr h="256660">
                 <a:tc>
                   <a:txBody>
                     <a:bodyPr wrap="square"/>
@@ -14818,7 +14816,7 @@
                           </a:solidFill>
                           <a:latin typeface="Calibri"/>
                         </a:rPr>
-                        <a:t>1,497.7</a:t>
+                        <a:t>25.0 min</a:t>
                       </a:r>
                     </a:p>
                   </a:txBody>
@@ -14875,7 +14873,7 @@
                   </a:tcPr>
                 </a:tc>
               </a:tr>
-              <a:tr h="257460">
+              <a:tr h="256660">
                 <a:tc>
                   <a:txBody>
                     <a:bodyPr wrap="square"/>
@@ -14912,7 +14910,7 @@
                           </a:solidFill>
                           <a:latin typeface="Calibri"/>
                         </a:rPr>
-                        <a:t>1,449.0</a:t>
+                        <a:t>24.1 min</a:t>
                       </a:r>
                     </a:p>
                   </a:txBody>
@@ -14969,7 +14967,7 @@
                   </a:tcPr>
                 </a:tc>
               </a:tr>
-              <a:tr h="257460">
+              <a:tr h="256660">
                 <a:tc>
                   <a:txBody>
                     <a:bodyPr wrap="square"/>
@@ -15006,7 +15004,7 @@
                           </a:solidFill>
                           <a:latin typeface="Calibri"/>
                         </a:rPr>
-                        <a:t>1,944.7</a:t>
+                        <a:t>32.4 min</a:t>
                       </a:r>
                     </a:p>
                   </a:txBody>
@@ -15052,7 +15050,7 @@
                           </a:solidFill>
                           <a:latin typeface="Calibri"/>
                         </a:rPr>
-                        <a:t>Tables 1 &amp; 2 – Formation Resistivity</a:t>
+                        <a:t>Tables 1 &amp; 2 – Formation Resistivity Factor</a:t>
                       </a:r>
                     </a:p>
                   </a:txBody>
@@ -15063,7 +15061,7 @@
                   </a:tcPr>
                 </a:tc>
               </a:tr>
-              <a:tr h="257460">
+              <a:tr h="256660">
                 <a:tc>
                   <a:txBody>
                     <a:bodyPr wrap="square"/>
@@ -15100,7 +15098,7 @@
                           </a:solidFill>
                           <a:latin typeface="Calibri"/>
                         </a:rPr>
-                        <a:t>1,434.4</a:t>
+                        <a:t>23.9 min</a:t>
                       </a:r>
                     </a:p>
                   </a:txBody>
@@ -15146,7 +15144,7 @@
                           </a:solidFill>
                           <a:latin typeface="Calibri"/>
                         </a:rPr>
-                        <a:t>Table 3 – Capillary Pressure</a:t>
+                        <a:t>Table 3 – Air-Brine Capillary Pressure</a:t>
                       </a:r>
                     </a:p>
                   </a:txBody>
@@ -15157,7 +15155,7 @@
                   </a:tcPr>
                 </a:tc>
               </a:tr>
-              <a:tr h="257460">
+              <a:tr h="256660">
                 <a:tc>
                   <a:txBody>
                     <a:bodyPr wrap="square"/>
@@ -15194,7 +15192,7 @@
                           </a:solidFill>
                           <a:latin typeface="Calibri"/>
                         </a:rPr>
-                        <a:t>755.8</a:t>
+                        <a:t>12.6 min</a:t>
                       </a:r>
                     </a:p>
                   </a:txBody>
@@ -15251,7 +15249,7 @@
                   </a:tcPr>
                 </a:tc>
               </a:tr>
-              <a:tr h="257460">
+              <a:tr h="256660">
                 <a:tc>
                   <a:txBody>
                     <a:bodyPr wrap="square"/>
@@ -15288,7 +15286,7 @@
                           </a:solidFill>
                           <a:latin typeface="Calibri"/>
                         </a:rPr>
-                        <a:t>98.0</a:t>
+                        <a:t>1.6 min</a:t>
                       </a:r>
                     </a:p>
                   </a:txBody>
@@ -15334,7 +15332,7 @@
                           </a:solidFill>
                           <a:latin typeface="Calibri"/>
                         </a:rPr>
-                        <a:t>Blank/spacer</a:t>
+                        <a:t>Blank / spacer page</a:t>
                       </a:r>
                     </a:p>
                   </a:txBody>
@@ -15345,7 +15343,7 @@
                   </a:tcPr>
                 </a:tc>
               </a:tr>
-              <a:tr h="257460">
+              <a:tr h="256660">
                 <a:tc>
                   <a:txBody>
                     <a:bodyPr wrap="square"/>
@@ -15382,7 +15380,7 @@
                           </a:solidFill>
                           <a:latin typeface="Calibri"/>
                         </a:rPr>
-                        <a:t>1,552.7</a:t>
+                        <a:t>25.9 min</a:t>
                       </a:r>
                     </a:p>
                   </a:txBody>
@@ -15439,7 +15437,7 @@
                   </a:tcPr>
                 </a:tc>
               </a:tr>
-              <a:tr h="257460">
+              <a:tr h="256660">
                 <a:tc>
                   <a:txBody>
                     <a:bodyPr wrap="square"/>
@@ -15476,7 +15474,7 @@
                           </a:solidFill>
                           <a:latin typeface="Calibri"/>
                         </a:rPr>
-                        <a:t>4,630.5</a:t>
+                        <a:t>1.3 hrs</a:t>
                       </a:r>
                     </a:p>
                   </a:txBody>
@@ -15533,7 +15531,7 @@
                   </a:tcPr>
                 </a:tc>
               </a:tr>
-              <a:tr h="257460">
+              <a:tr h="256660">
                 <a:tc>
                   <a:txBody>
                     <a:bodyPr wrap="square"/>
@@ -15570,7 +15568,7 @@
                           </a:solidFill>
                           <a:latin typeface="Calibri"/>
                         </a:rPr>
-                        <a:t>2,341.4</a:t>
+                        <a:t>39.0 min</a:t>
                       </a:r>
                     </a:p>
                   </a:txBody>
@@ -15627,7 +15625,7 @@
                   </a:tcPr>
                 </a:tc>
               </a:tr>
-              <a:tr h="257460">
+              <a:tr h="256660">
                 <a:tc>
                   <a:txBody>
                     <a:bodyPr wrap="square"/>
@@ -15664,7 +15662,7 @@
                           </a:solidFill>
                           <a:latin typeface="Calibri"/>
                         </a:rPr>
-                        <a:t>1,286.0</a:t>
+                        <a:t>21.4 min</a:t>
                       </a:r>
                     </a:p>
                   </a:txBody>
@@ -15721,7 +15719,7 @@
                   </a:tcPr>
                 </a:tc>
               </a:tr>
-              <a:tr h="257460">
+              <a:tr h="256660">
                 <a:tc>
                   <a:txBody>
                     <a:bodyPr wrap="square"/>
@@ -15758,7 +15756,7 @@
                           </a:solidFill>
                           <a:latin typeface="Calibri"/>
                         </a:rPr>
-                        <a:t>10,454.7</a:t>
+                        <a:t>2.9 hrs</a:t>
                       </a:r>
                     </a:p>
                   </a:txBody>
@@ -15815,7 +15813,7 @@
                   </a:tcPr>
                 </a:tc>
               </a:tr>
-              <a:tr h="257460">
+              <a:tr h="256660">
                 <a:tc>
                   <a:txBody>
                     <a:bodyPr wrap="square"/>
@@ -15852,7 +15850,7 @@
                           </a:solidFill>
                           <a:latin typeface="Calibri"/>
                         </a:rPr>
-                        <a:t>3,547.0</a:t>
+                        <a:t>59.1 min</a:t>
                       </a:r>
                     </a:p>
                   </a:txBody>
@@ -15909,7 +15907,7 @@
                   </a:tcPr>
                 </a:tc>
               </a:tr>
-              <a:tr h="257460">
+              <a:tr h="256660">
                 <a:tc>
                   <a:txBody>
                     <a:bodyPr wrap="square"/>
@@ -15946,7 +15944,7 @@
                           </a:solidFill>
                           <a:latin typeface="Calibri"/>
                         </a:rPr>
-                        <a:t>11,389.3</a:t>
+                        <a:t>3.2 hrs</a:t>
                       </a:r>
                     </a:p>
                   </a:txBody>
@@ -16003,7 +16001,7 @@
                   </a:tcPr>
                 </a:tc>
               </a:tr>
-              <a:tr h="257460">
+              <a:tr h="256660">
                 <a:tc>
                   <a:txBody>
                     <a:bodyPr wrap="square"/>
@@ -16040,7 +16038,7 @@
                           </a:solidFill>
                           <a:latin typeface="Calibri"/>
                         </a:rPr>
-                        <a:t>4,001.6</a:t>
+                        <a:t>1.1 hrs</a:t>
                       </a:r>
                     </a:p>
                   </a:txBody>
@@ -16097,7 +16095,7 @@
                   </a:tcPr>
                 </a:tc>
               </a:tr>
-              <a:tr h="257460">
+              <a:tr h="256660">
                 <a:tc>
                   <a:txBody>
                     <a:bodyPr wrap="square"/>
@@ -16134,7 +16132,7 @@
                           </a:solidFill>
                           <a:latin typeface="Calibri"/>
                         </a:rPr>
-                        <a:t>11,992.5</a:t>
+                        <a:t>3.3 hrs</a:t>
                       </a:r>
                     </a:p>
                   </a:txBody>
@@ -16191,7 +16189,7 @@
                   </a:tcPr>
                 </a:tc>
               </a:tr>
-              <a:tr h="257460">
+              <a:tr h="256660">
                 <a:tc>
                   <a:txBody>
                     <a:bodyPr wrap="square"/>
@@ -16228,7 +16226,7 @@
                           </a:solidFill>
                           <a:latin typeface="Calibri"/>
                         </a:rPr>
-                        <a:t>4,509.3</a:t>
+                        <a:t>1.3 hrs</a:t>
                       </a:r>
                     </a:p>
                   </a:txBody>
@@ -16285,7 +16283,7 @@
                   </a:tcPr>
                 </a:tc>
               </a:tr>
-              <a:tr h="257460">
+              <a:tr h="256660">
                 <a:tc>
                   <a:txBody>
                     <a:bodyPr wrap="square"/>
@@ -16322,7 +16320,7 @@
                           </a:solidFill>
                           <a:latin typeface="Calibri"/>
                         </a:rPr>
-                        <a:t>12,060.6</a:t>
+                        <a:t>3.4 hrs</a:t>
                       </a:r>
                     </a:p>
                   </a:txBody>
@@ -16379,7 +16377,7 @@
                   </a:tcPr>
                 </a:tc>
               </a:tr>
-              <a:tr h="257460">
+              <a:tr h="256660">
                 <a:tc>
                   <a:txBody>
                     <a:bodyPr wrap="square"/>
@@ -16416,7 +16414,7 @@
                           </a:solidFill>
                           <a:latin typeface="Calibri"/>
                         </a:rPr>
-                        <a:t>4,809.3</a:t>
+                        <a:t>1.3 hrs</a:t>
                       </a:r>
                     </a:p>
                   </a:txBody>
@@ -16473,7 +16471,7 @@
                   </a:tcPr>
                 </a:tc>
               </a:tr>
-              <a:tr h="257460">
+              <a:tr h="256660">
                 <a:tc>
                   <a:txBody>
                     <a:bodyPr wrap="square"/>
@@ -16510,7 +16508,7 @@
                           </a:solidFill>
                           <a:latin typeface="Calibri"/>
                         </a:rPr>
-                        <a:t>236.8</a:t>
+                        <a:t>3.9 min</a:t>
                       </a:r>
                     </a:p>
                   </a:txBody>
@@ -16567,7 +16565,7 @@
                   </a:tcPr>
                 </a:tc>
               </a:tr>
-              <a:tr h="257460">
+              <a:tr h="256660">
                 <a:tc>
                   <a:txBody>
                     <a:bodyPr wrap="square"/>
@@ -16581,30 +16579,30 @@
                           </a:solidFill>
                           <a:latin typeface="Calibri"/>
                         </a:rPr>
-                        <a:t>24-38</a:t>
-                      </a:r>
-                    </a:p>
-                  </a:txBody>
-                  <a:tcPr>
-                    <a:solidFill>
-                      <a:srgbClr val="FFFFFF"/>
-                    </a:solidFill>
-                  </a:tcPr>
-                </a:tc>
-                <a:tc>
-                  <a:txBody>
-                    <a:bodyPr wrap="square"/>
-                    <a:lstStyle/>
-                    <a:p>
-                      <a:pPr algn="ctr"/>
-                      <a:r>
-                        <a:rPr sz="1000" b="0">
-                          <a:solidFill>
-                            <a:srgbClr val="000000"/>
-                          </a:solidFill>
-                          <a:latin typeface="Calibri"/>
-                        </a:rPr>
-                        <a:t>~8,821.5</a:t>
+                        <a:t>24–38</a:t>
+                      </a:r>
+                    </a:p>
+                  </a:txBody>
+                  <a:tcPr>
+                    <a:solidFill>
+                      <a:srgbClr val="FFFFFF"/>
+                    </a:solidFill>
+                  </a:tcPr>
+                </a:tc>
+                <a:tc>
+                  <a:txBody>
+                    <a:bodyPr wrap="square"/>
+                    <a:lstStyle/>
+                    <a:p>
+                      <a:pPr algn="ctr"/>
+                      <a:r>
+                        <a:rPr sz="1000" b="0">
+                          <a:solidFill>
+                            <a:srgbClr val="000000"/>
+                          </a:solidFill>
+                          <a:latin typeface="Calibri"/>
+                        </a:rPr>
+                        <a:t>~2.5 hrs</a:t>
                       </a:r>
                     </a:p>
                   </a:txBody>
@@ -16673,8 +16671,8 @@
         </p:nvSpPr>
         <p:spPr>
           <a:xfrm>
-            <a:off x="350000" y="7356500"/>
-            <a:ext cx="9993400" cy="190000"/>
+            <a:off x="350000" y="7346500"/>
+            <a:ext cx="9993400" cy="200000"/>
           </a:xfrm>
           <a:prstGeom prst="rect">
             <a:avLst/>
@@ -16696,7 +16694,7 @@
                   <a:srgbClr val="595959"/>
                 </a:solidFill>
               </a:rPr>
-              <a:t>TOTAL:  38 pages  |  91,809.4 s (~25.5 hrs)  |  95,039 tokens  |  4 samples (depths 3184–3598.5 m)  |  Complex graph pages 15, 17, 19, 21 took 10,000–12,061 s each</a:t>
+              <a:t>TOTAL:  38 pages  |  25.5 hrs  |  95,039 tokens  |  4 samples (depths 3184–3598.5 m)  |  Complex graph pages 15, 17, 19, 21 — each 2.9–3.3 hrs</a:t>
             </a:r>
           </a:p>
         </p:txBody>
@@ -16710,1167 +16708,6 @@
 </file>
 
 <file path=ppt/slides/slide24.xml><?xml version="1.0" encoding="utf-8"?>
-<p:sld xmlns:a="http://schemas.openxmlformats.org/drawingml/2006/main" xmlns:p="http://schemas.openxmlformats.org/presentationml/2006/main" xmlns:r="http://schemas.openxmlformats.org/officeDocument/2006/relationships">
-  <p:cSld>
-    <p:spTree>
-      <p:nvGrpSpPr>
-        <p:cNvPr id="1" name=""/>
-        <p:cNvGrpSpPr/>
-        <p:nvPr/>
-      </p:nvGrpSpPr>
-      <p:grpSpPr/>
-      <p:sp>
-        <p:nvSpPr>
-          <p:cNvPr id="2" name="Title 1"/>
-          <p:cNvSpPr>
-            <a:spLocks noGrp="1"/>
-          </p:cNvSpPr>
-          <p:nvPr>
-            <p:ph type="title"/>
-          </p:nvPr>
-        </p:nvSpPr>
-        <p:spPr/>
-        <p:txBody>
-          <a:bodyPr/>
-          <a:lstStyle/>
-          <a:p/>
-        </p:txBody>
-      </p:sp>
-      <p:sp>
-        <p:nvSpPr>
-          <p:cNvPr id="3" name="Text Placeholder 2"/>
-          <p:cNvSpPr>
-            <a:spLocks noGrp="1"/>
-          </p:cNvSpPr>
-          <p:nvPr>
-            <p:ph type="body" idx="1"/>
-          </p:nvPr>
-        </p:nvSpPr>
-        <p:spPr/>
-        <p:txBody>
-          <a:bodyPr/>
-          <a:lstStyle/>
-          <a:p/>
-        </p:txBody>
-      </p:sp>
-      <p:sp>
-        <p:nvSpPr>
-          <p:cNvPr id="4" name="TextBox 3"/>
-          <p:cNvSpPr txBox="1"/>
-          <p:nvPr/>
-        </p:nvSpPr>
-        <p:spPr>
-          <a:xfrm>
-            <a:off x="350000" y="80000"/>
-            <a:ext cx="9993400" cy="480000"/>
-          </a:xfrm>
-          <a:prstGeom prst="rect">
-            <a:avLst/>
-          </a:prstGeom>
-          <a:noFill/>
-        </p:spPr>
-        <p:txBody>
-          <a:bodyPr wrap="square" anchor="t">
-            <a:spAutoFit/>
-          </a:bodyPr>
-          <a:lstStyle/>
-          <a:p>
-            <a:pPr algn="l">
-              <a:buNone/>
-            </a:pPr>
-            <a:r>
-              <a:rPr lang="en-US" sz="2200" b="1" dirty="0">
-                <a:solidFill>
-                  <a:srgbClr val="002060"/>
-                </a:solidFill>
-              </a:rPr>
-              <a:t>Duyong Deep 1 — Key SCAL Results</a:t>
-            </a:r>
-          </a:p>
-        </p:txBody>
-      </p:sp>
-      <p:sp>
-        <p:nvSpPr>
-          <p:cNvPr id="5" name="TextBox 4"/>
-          <p:cNvSpPr txBox="1"/>
-          <p:nvPr/>
-        </p:nvSpPr>
-        <p:spPr>
-          <a:xfrm>
-            <a:off x="350000" y="590000"/>
-            <a:ext cx="9993400" cy="280000"/>
-          </a:xfrm>
-          <a:prstGeom prst="rect">
-            <a:avLst/>
-          </a:prstGeom>
-          <a:noFill/>
-        </p:spPr>
-        <p:txBody>
-          <a:bodyPr wrap="square" anchor="t">
-            <a:spAutoFit/>
-          </a:bodyPr>
-          <a:lstStyle/>
-          <a:p>
-            <a:pPr algn="l">
-              <a:buNone/>
-            </a:pPr>
-            <a:r>
-              <a:rPr lang="en-US" sz="1200" dirty="0">
-                <a:solidFill>
-                  <a:srgbClr val="595959"/>
-                </a:solidFill>
-              </a:rPr>
-              <a:t>4 rotary sidewall core samples from Block PM12, Offshore Peninsular Malaysia  |  Well drilled by PETRONAS CARIGALI</a:t>
-            </a:r>
-          </a:p>
-        </p:txBody>
-      </p:sp>
-      <p:graphicFrame>
-        <p:nvGraphicFramePr>
-          <p:cNvPr id="6" name="Table 5"/>
-          <p:cNvGraphicFramePr>
-            <a:graphicFrameLocks noGrp="1"/>
-          </p:cNvGraphicFramePr>
-          <p:nvPr/>
-        </p:nvGraphicFramePr>
-        <p:xfrm>
-          <a:off x="350000" y="920000"/>
-          <a:ext cx="9993400" cy="1900000"/>
-        </p:xfrm>
-        <a:graphic>
-          <a:graphicData uri="http://schemas.openxmlformats.org/drawingml/2006/table">
-            <a:tbl>
-              <a:tblPr firstRow="1" bandRow="1">
-                <a:tableStyleId>{5C22544A-7EE6-4342-B048-85BDC9FD1C3A}</a:tableStyleId>
-              </a:tblPr>
-              <a:tblGrid>
-                <a:gridCol w="1199208"/>
-                <a:gridCol w="1199208"/>
-                <a:gridCol w="1698878"/>
-                <a:gridCol w="1499010"/>
-                <a:gridCol w="1499010"/>
-                <a:gridCol w="1399076"/>
-                <a:gridCol w="1499010"/>
-              </a:tblGrid>
-              <a:tr h="380000">
-                <a:tc>
-                  <a:txBody>
-                    <a:bodyPr wrap="square"/>
-                    <a:lstStyle/>
-                    <a:p>
-                      <a:pPr algn="ctr"/>
-                      <a:r>
-                        <a:rPr sz="1200" b="1">
-                          <a:solidFill>
-                            <a:srgbClr val="FFFFFF"/>
-                          </a:solidFill>
-                          <a:latin typeface="Calibri"/>
-                        </a:rPr>
-                        <a:t>Sample ID</a:t>
-                      </a:r>
-                    </a:p>
-                  </a:txBody>
-                  <a:tcPr>
-                    <a:solidFill>
-                      <a:srgbClr val="002060"/>
-                    </a:solidFill>
-                  </a:tcPr>
-                </a:tc>
-                <a:tc>
-                  <a:txBody>
-                    <a:bodyPr wrap="square"/>
-                    <a:lstStyle/>
-                    <a:p>
-                      <a:pPr algn="ctr"/>
-                      <a:r>
-                        <a:rPr sz="1200" b="1">
-                          <a:solidFill>
-                            <a:srgbClr val="FFFFFF"/>
-                          </a:solidFill>
-                          <a:latin typeface="Calibri"/>
-                        </a:rPr>
-                        <a:t>Depth (m)</a:t>
-                      </a:r>
-                    </a:p>
-                  </a:txBody>
-                  <a:tcPr>
-                    <a:solidFill>
-                      <a:srgbClr val="002060"/>
-                    </a:solidFill>
-                  </a:tcPr>
-                </a:tc>
-                <a:tc>
-                  <a:txBody>
-                    <a:bodyPr wrap="square"/>
-                    <a:lstStyle/>
-                    <a:p>
-                      <a:pPr algn="ctr"/>
-                      <a:r>
-                        <a:rPr sz="1200" b="1">
-                          <a:solidFill>
-                            <a:srgbClr val="FFFFFF"/>
-                          </a:solidFill>
-                          <a:latin typeface="Calibri"/>
-                        </a:rPr>
-                        <a:t>Formation Factor (F)</a:t>
-                      </a:r>
-                    </a:p>
-                  </a:txBody>
-                  <a:tcPr>
-                    <a:solidFill>
-                      <a:srgbClr val="002060"/>
-                    </a:solidFill>
-                  </a:tcPr>
-                </a:tc>
-                <a:tc>
-                  <a:txBody>
-                    <a:bodyPr wrap="square"/>
-                    <a:lstStyle/>
-                    <a:p>
-                      <a:pPr algn="ctr"/>
-                      <a:r>
-                        <a:rPr sz="1200" b="1">
-                          <a:solidFill>
-                            <a:srgbClr val="FFFFFF"/>
-                          </a:solidFill>
-                          <a:latin typeface="Calibri"/>
-                        </a:rPr>
-                        <a:t>Cementation Exp. (m)</a:t>
-                      </a:r>
-                    </a:p>
-                  </a:txBody>
-                  <a:tcPr>
-                    <a:solidFill>
-                      <a:srgbClr val="002060"/>
-                    </a:solidFill>
-                  </a:tcPr>
-                </a:tc>
-                <a:tc>
-                  <a:txBody>
-                    <a:bodyPr wrap="square"/>
-                    <a:lstStyle/>
-                    <a:p>
-                      <a:pPr algn="ctr"/>
-                      <a:r>
-                        <a:rPr sz="1200" b="1">
-                          <a:solidFill>
-                            <a:srgbClr val="FFFFFF"/>
-                          </a:solidFill>
-                          <a:latin typeface="Calibri"/>
-                        </a:rPr>
-                        <a:t>Saturation Exp. (n)</a:t>
-                      </a:r>
-                    </a:p>
-                  </a:txBody>
-                  <a:tcPr>
-                    <a:solidFill>
-                      <a:srgbClr val="002060"/>
-                    </a:solidFill>
-                  </a:tcPr>
-                </a:tc>
-                <a:tc>
-                  <a:txBody>
-                    <a:bodyPr wrap="square"/>
-                    <a:lstStyle/>
-                    <a:p>
-                      <a:pPr algn="ctr"/>
-                      <a:r>
-                        <a:rPr sz="1200" b="1">
-                          <a:solidFill>
-                            <a:srgbClr val="FFFFFF"/>
-                          </a:solidFill>
-                          <a:latin typeface="Calibri"/>
-                        </a:rPr>
-                        <a:t>CEC (meq/100g)</a:t>
-                      </a:r>
-                    </a:p>
-                  </a:txBody>
-                  <a:tcPr>
-                    <a:solidFill>
-                      <a:srgbClr val="002060"/>
-                    </a:solidFill>
-                  </a:tcPr>
-                </a:tc>
-                <a:tc>
-                  <a:txBody>
-                    <a:bodyPr wrap="square"/>
-                    <a:lstStyle/>
-                    <a:p>
-                      <a:pPr algn="ctr"/>
-                      <a:r>
-                        <a:rPr sz="1200" b="1">
-                          <a:solidFill>
-                            <a:srgbClr val="FFFFFF"/>
-                          </a:solidFill>
-                          <a:latin typeface="Calibri"/>
-                        </a:rPr>
-                        <a:t>Swi at Max Drainage (%)</a:t>
-                      </a:r>
-                    </a:p>
-                  </a:txBody>
-                  <a:tcPr>
-                    <a:solidFill>
-                      <a:srgbClr val="002060"/>
-                    </a:solidFill>
-                  </a:tcPr>
-                </a:tc>
-              </a:tr>
-              <a:tr h="380000">
-                <a:tc>
-                  <a:txBody>
-                    <a:bodyPr wrap="square"/>
-                    <a:lstStyle/>
-                    <a:p>
-                      <a:pPr algn="l"/>
-                      <a:r>
-                        <a:rPr sz="1100" b="0">
-                          <a:solidFill>
-                            <a:srgbClr val="000000"/>
-                          </a:solidFill>
-                          <a:latin typeface="Calibri"/>
-                        </a:rPr>
-                        <a:t>2</a:t>
-                      </a:r>
-                    </a:p>
-                  </a:txBody>
-                  <a:tcPr>
-                    <a:solidFill>
-                      <a:srgbClr val="F2F2F2"/>
-                    </a:solidFill>
-                  </a:tcPr>
-                </a:tc>
-                <a:tc>
-                  <a:txBody>
-                    <a:bodyPr wrap="square"/>
-                    <a:lstStyle/>
-                    <a:p>
-                      <a:pPr algn="ctr"/>
-                      <a:r>
-                        <a:rPr sz="1100" b="0">
-                          <a:solidFill>
-                            <a:srgbClr val="000000"/>
-                          </a:solidFill>
-                          <a:latin typeface="Calibri"/>
-                        </a:rPr>
-                        <a:t>3184.0</a:t>
-                      </a:r>
-                    </a:p>
-                  </a:txBody>
-                  <a:tcPr>
-                    <a:solidFill>
-                      <a:srgbClr val="F2F2F2"/>
-                    </a:solidFill>
-                  </a:tcPr>
-                </a:tc>
-                <a:tc>
-                  <a:txBody>
-                    <a:bodyPr wrap="square"/>
-                    <a:lstStyle/>
-                    <a:p>
-                      <a:pPr algn="ctr"/>
-                      <a:r>
-                        <a:rPr sz="1100" b="0">
-                          <a:solidFill>
-                            <a:srgbClr val="000000"/>
-                          </a:solidFill>
-                          <a:latin typeface="Calibri"/>
-                        </a:rPr>
-                        <a:t>—</a:t>
-                      </a:r>
-                    </a:p>
-                  </a:txBody>
-                  <a:tcPr>
-                    <a:solidFill>
-                      <a:srgbClr val="F2F2F2"/>
-                    </a:solidFill>
-                  </a:tcPr>
-                </a:tc>
-                <a:tc>
-                  <a:txBody>
-                    <a:bodyPr wrap="square"/>
-                    <a:lstStyle/>
-                    <a:p>
-                      <a:pPr algn="ctr"/>
-                      <a:r>
-                        <a:rPr sz="1100" b="0">
-                          <a:solidFill>
-                            <a:srgbClr val="000000"/>
-                          </a:solidFill>
-                          <a:latin typeface="Calibri"/>
-                        </a:rPr>
-                        <a:t>1.83</a:t>
-                      </a:r>
-                    </a:p>
-                  </a:txBody>
-                  <a:tcPr>
-                    <a:solidFill>
-                      <a:srgbClr val="F2F2F2"/>
-                    </a:solidFill>
-                  </a:tcPr>
-                </a:tc>
-                <a:tc>
-                  <a:txBody>
-                    <a:bodyPr wrap="square"/>
-                    <a:lstStyle/>
-                    <a:p>
-                      <a:pPr algn="ctr"/>
-                      <a:r>
-                        <a:rPr sz="1100" b="0">
-                          <a:solidFill>
-                            <a:srgbClr val="000000"/>
-                          </a:solidFill>
-                          <a:latin typeface="Calibri"/>
-                        </a:rPr>
-                        <a:t>1.87</a:t>
-                      </a:r>
-                    </a:p>
-                  </a:txBody>
-                  <a:tcPr>
-                    <a:solidFill>
-                      <a:srgbClr val="F2F2F2"/>
-                    </a:solidFill>
-                  </a:tcPr>
-                </a:tc>
-                <a:tc>
-                  <a:txBody>
-                    <a:bodyPr wrap="square"/>
-                    <a:lstStyle/>
-                    <a:p>
-                      <a:pPr algn="ctr"/>
-                      <a:r>
-                        <a:rPr sz="1100" b="0">
-                          <a:solidFill>
-                            <a:srgbClr val="000000"/>
-                          </a:solidFill>
-                          <a:latin typeface="Calibri"/>
-                        </a:rPr>
-                        <a:t>1.08</a:t>
-                      </a:r>
-                    </a:p>
-                  </a:txBody>
-                  <a:tcPr>
-                    <a:solidFill>
-                      <a:srgbClr val="F2F2F2"/>
-                    </a:solidFill>
-                  </a:tcPr>
-                </a:tc>
-                <a:tc>
-                  <a:txBody>
-                    <a:bodyPr wrap="square"/>
-                    <a:lstStyle/>
-                    <a:p>
-                      <a:pPr algn="ctr"/>
-                      <a:r>
-                        <a:rPr sz="1100" b="0">
-                          <a:solidFill>
-                            <a:srgbClr val="000000"/>
-                          </a:solidFill>
-                          <a:latin typeface="Calibri"/>
-                        </a:rPr>
-                        <a:t>83.7</a:t>
-                      </a:r>
-                    </a:p>
-                  </a:txBody>
-                  <a:tcPr>
-                    <a:solidFill>
-                      <a:srgbClr val="F2F2F2"/>
-                    </a:solidFill>
-                  </a:tcPr>
-                </a:tc>
-              </a:tr>
-              <a:tr h="380000">
-                <a:tc>
-                  <a:txBody>
-                    <a:bodyPr wrap="square"/>
-                    <a:lstStyle/>
-                    <a:p>
-                      <a:pPr algn="l"/>
-                      <a:r>
-                        <a:rPr sz="1100" b="0">
-                          <a:solidFill>
-                            <a:srgbClr val="000000"/>
-                          </a:solidFill>
-                          <a:latin typeface="Calibri"/>
-                        </a:rPr>
-                        <a:t>3</a:t>
-                      </a:r>
-                    </a:p>
-                  </a:txBody>
-                  <a:tcPr>
-                    <a:solidFill>
-                      <a:srgbClr val="FFFFFF"/>
-                    </a:solidFill>
-                  </a:tcPr>
-                </a:tc>
-                <a:tc>
-                  <a:txBody>
-                    <a:bodyPr wrap="square"/>
-                    <a:lstStyle/>
-                    <a:p>
-                      <a:pPr algn="ctr"/>
-                      <a:r>
-                        <a:rPr sz="1100" b="0">
-                          <a:solidFill>
-                            <a:srgbClr val="000000"/>
-                          </a:solidFill>
-                          <a:latin typeface="Calibri"/>
-                        </a:rPr>
-                        <a:t>3528.0</a:t>
-                      </a:r>
-                    </a:p>
-                  </a:txBody>
-                  <a:tcPr>
-                    <a:solidFill>
-                      <a:srgbClr val="FFFFFF"/>
-                    </a:solidFill>
-                  </a:tcPr>
-                </a:tc>
-                <a:tc>
-                  <a:txBody>
-                    <a:bodyPr wrap="square"/>
-                    <a:lstStyle/>
-                    <a:p>
-                      <a:pPr algn="ctr"/>
-                      <a:r>
-                        <a:rPr sz="1100" b="0">
-                          <a:solidFill>
-                            <a:srgbClr val="000000"/>
-                          </a:solidFill>
-                          <a:latin typeface="Calibri"/>
-                        </a:rPr>
-                        <a:t>—</a:t>
-                      </a:r>
-                    </a:p>
-                  </a:txBody>
-                  <a:tcPr>
-                    <a:solidFill>
-                      <a:srgbClr val="FFFFFF"/>
-                    </a:solidFill>
-                  </a:tcPr>
-                </a:tc>
-                <a:tc>
-                  <a:txBody>
-                    <a:bodyPr wrap="square"/>
-                    <a:lstStyle/>
-                    <a:p>
-                      <a:pPr algn="ctr"/>
-                      <a:r>
-                        <a:rPr sz="1100" b="0">
-                          <a:solidFill>
-                            <a:srgbClr val="000000"/>
-                          </a:solidFill>
-                          <a:latin typeface="Calibri"/>
-                        </a:rPr>
-                        <a:t>~1.84</a:t>
-                      </a:r>
-                    </a:p>
-                  </a:txBody>
-                  <a:tcPr>
-                    <a:solidFill>
-                      <a:srgbClr val="FFFFFF"/>
-                    </a:solidFill>
-                  </a:tcPr>
-                </a:tc>
-                <a:tc>
-                  <a:txBody>
-                    <a:bodyPr wrap="square"/>
-                    <a:lstStyle/>
-                    <a:p>
-                      <a:pPr algn="ctr"/>
-                      <a:r>
-                        <a:rPr sz="1100" b="0">
-                          <a:solidFill>
-                            <a:srgbClr val="000000"/>
-                          </a:solidFill>
-                          <a:latin typeface="Calibri"/>
-                        </a:rPr>
-                        <a:t>~1.88</a:t>
-                      </a:r>
-                    </a:p>
-                  </a:txBody>
-                  <a:tcPr>
-                    <a:solidFill>
-                      <a:srgbClr val="FFFFFF"/>
-                    </a:solidFill>
-                  </a:tcPr>
-                </a:tc>
-                <a:tc>
-                  <a:txBody>
-                    <a:bodyPr wrap="square"/>
-                    <a:lstStyle/>
-                    <a:p>
-                      <a:pPr algn="ctr"/>
-                      <a:r>
-                        <a:rPr sz="1100" b="0">
-                          <a:solidFill>
-                            <a:srgbClr val="000000"/>
-                          </a:solidFill>
-                          <a:latin typeface="Calibri"/>
-                        </a:rPr>
-                        <a:t>~1.12</a:t>
-                      </a:r>
-                    </a:p>
-                  </a:txBody>
-                  <a:tcPr>
-                    <a:solidFill>
-                      <a:srgbClr val="FFFFFF"/>
-                    </a:solidFill>
-                  </a:tcPr>
-                </a:tc>
-                <a:tc>
-                  <a:txBody>
-                    <a:bodyPr wrap="square"/>
-                    <a:lstStyle/>
-                    <a:p>
-                      <a:pPr algn="ctr"/>
-                      <a:r>
-                        <a:rPr sz="1100" b="0">
-                          <a:solidFill>
-                            <a:srgbClr val="000000"/>
-                          </a:solidFill>
-                          <a:latin typeface="Calibri"/>
-                        </a:rPr>
-                        <a:t>Very tight</a:t>
-                      </a:r>
-                    </a:p>
-                  </a:txBody>
-                  <a:tcPr>
-                    <a:solidFill>
-                      <a:srgbClr val="FFFFFF"/>
-                    </a:solidFill>
-                  </a:tcPr>
-                </a:tc>
-              </a:tr>
-              <a:tr h="380000">
-                <a:tc>
-                  <a:txBody>
-                    <a:bodyPr wrap="square"/>
-                    <a:lstStyle/>
-                    <a:p>
-                      <a:pPr algn="l"/>
-                      <a:r>
-                        <a:rPr sz="1100" b="0">
-                          <a:solidFill>
-                            <a:srgbClr val="000000"/>
-                          </a:solidFill>
-                          <a:latin typeface="Calibri"/>
-                        </a:rPr>
-                        <a:t>4</a:t>
-                      </a:r>
-                    </a:p>
-                  </a:txBody>
-                  <a:tcPr>
-                    <a:solidFill>
-                      <a:srgbClr val="F2F2F2"/>
-                    </a:solidFill>
-                  </a:tcPr>
-                </a:tc>
-                <a:tc>
-                  <a:txBody>
-                    <a:bodyPr wrap="square"/>
-                    <a:lstStyle/>
-                    <a:p>
-                      <a:pPr algn="ctr"/>
-                      <a:r>
-                        <a:rPr sz="1100" b="0">
-                          <a:solidFill>
-                            <a:srgbClr val="000000"/>
-                          </a:solidFill>
-                          <a:latin typeface="Calibri"/>
-                        </a:rPr>
-                        <a:t>3576.0</a:t>
-                      </a:r>
-                    </a:p>
-                  </a:txBody>
-                  <a:tcPr>
-                    <a:solidFill>
-                      <a:srgbClr val="F2F2F2"/>
-                    </a:solidFill>
-                  </a:tcPr>
-                </a:tc>
-                <a:tc>
-                  <a:txBody>
-                    <a:bodyPr wrap="square"/>
-                    <a:lstStyle/>
-                    <a:p>
-                      <a:pPr algn="ctr"/>
-                      <a:r>
-                        <a:rPr sz="1100" b="0">
-                          <a:solidFill>
-                            <a:srgbClr val="000000"/>
-                          </a:solidFill>
-                          <a:latin typeface="Calibri"/>
-                        </a:rPr>
-                        <a:t>—</a:t>
-                      </a:r>
-                    </a:p>
-                  </a:txBody>
-                  <a:tcPr>
-                    <a:solidFill>
-                      <a:srgbClr val="F2F2F2"/>
-                    </a:solidFill>
-                  </a:tcPr>
-                </a:tc>
-                <a:tc>
-                  <a:txBody>
-                    <a:bodyPr wrap="square"/>
-                    <a:lstStyle/>
-                    <a:p>
-                      <a:pPr algn="ctr"/>
-                      <a:r>
-                        <a:rPr sz="1100" b="0">
-                          <a:solidFill>
-                            <a:srgbClr val="000000"/>
-                          </a:solidFill>
-                          <a:latin typeface="Calibri"/>
-                        </a:rPr>
-                        <a:t>~1.85</a:t>
-                      </a:r>
-                    </a:p>
-                  </a:txBody>
-                  <a:tcPr>
-                    <a:solidFill>
-                      <a:srgbClr val="F2F2F2"/>
-                    </a:solidFill>
-                  </a:tcPr>
-                </a:tc>
-                <a:tc>
-                  <a:txBody>
-                    <a:bodyPr wrap="square"/>
-                    <a:lstStyle/>
-                    <a:p>
-                      <a:pPr algn="ctr"/>
-                      <a:r>
-                        <a:rPr sz="1100" b="0">
-                          <a:solidFill>
-                            <a:srgbClr val="000000"/>
-                          </a:solidFill>
-                          <a:latin typeface="Calibri"/>
-                        </a:rPr>
-                        <a:t>~1.90</a:t>
-                      </a:r>
-                    </a:p>
-                  </a:txBody>
-                  <a:tcPr>
-                    <a:solidFill>
-                      <a:srgbClr val="F2F2F2"/>
-                    </a:solidFill>
-                  </a:tcPr>
-                </a:tc>
-                <a:tc>
-                  <a:txBody>
-                    <a:bodyPr wrap="square"/>
-                    <a:lstStyle/>
-                    <a:p>
-                      <a:pPr algn="ctr"/>
-                      <a:r>
-                        <a:rPr sz="1100" b="0">
-                          <a:solidFill>
-                            <a:srgbClr val="000000"/>
-                          </a:solidFill>
-                          <a:latin typeface="Calibri"/>
-                        </a:rPr>
-                        <a:t>~1.14</a:t>
-                      </a:r>
-                    </a:p>
-                  </a:txBody>
-                  <a:tcPr>
-                    <a:solidFill>
-                      <a:srgbClr val="F2F2F2"/>
-                    </a:solidFill>
-                  </a:tcPr>
-                </a:tc>
-                <a:tc>
-                  <a:txBody>
-                    <a:bodyPr wrap="square"/>
-                    <a:lstStyle/>
-                    <a:p>
-                      <a:pPr algn="ctr"/>
-                      <a:r>
-                        <a:rPr sz="1100" b="0">
-                          <a:solidFill>
-                            <a:srgbClr val="000000"/>
-                          </a:solidFill>
-                          <a:latin typeface="Calibri"/>
-                        </a:rPr>
-                        <a:t>Very tight</a:t>
-                      </a:r>
-                    </a:p>
-                  </a:txBody>
-                  <a:tcPr>
-                    <a:solidFill>
-                      <a:srgbClr val="F2F2F2"/>
-                    </a:solidFill>
-                  </a:tcPr>
-                </a:tc>
-              </a:tr>
-              <a:tr h="380000">
-                <a:tc>
-                  <a:txBody>
-                    <a:bodyPr wrap="square"/>
-                    <a:lstStyle/>
-                    <a:p>
-                      <a:pPr algn="l"/>
-                      <a:r>
-                        <a:rPr sz="1100" b="0">
-                          <a:solidFill>
-                            <a:srgbClr val="000000"/>
-                          </a:solidFill>
-                          <a:latin typeface="Calibri"/>
-                        </a:rPr>
-                        <a:t>6</a:t>
-                      </a:r>
-                    </a:p>
-                  </a:txBody>
-                  <a:tcPr>
-                    <a:solidFill>
-                      <a:srgbClr val="FFFFFF"/>
-                    </a:solidFill>
-                  </a:tcPr>
-                </a:tc>
-                <a:tc>
-                  <a:txBody>
-                    <a:bodyPr wrap="square"/>
-                    <a:lstStyle/>
-                    <a:p>
-                      <a:pPr algn="ctr"/>
-                      <a:r>
-                        <a:rPr sz="1100" b="0">
-                          <a:solidFill>
-                            <a:srgbClr val="000000"/>
-                          </a:solidFill>
-                          <a:latin typeface="Calibri"/>
-                        </a:rPr>
-                        <a:t>3598.5</a:t>
-                      </a:r>
-                    </a:p>
-                  </a:txBody>
-                  <a:tcPr>
-                    <a:solidFill>
-                      <a:srgbClr val="FFFFFF"/>
-                    </a:solidFill>
-                  </a:tcPr>
-                </a:tc>
-                <a:tc>
-                  <a:txBody>
-                    <a:bodyPr wrap="square"/>
-                    <a:lstStyle/>
-                    <a:p>
-                      <a:pPr algn="ctr"/>
-                      <a:r>
-                        <a:rPr sz="1100" b="0">
-                          <a:solidFill>
-                            <a:srgbClr val="000000"/>
-                          </a:solidFill>
-                          <a:latin typeface="Calibri"/>
-                        </a:rPr>
-                        <a:t>—</a:t>
-                      </a:r>
-                    </a:p>
-                  </a:txBody>
-                  <a:tcPr>
-                    <a:solidFill>
-                      <a:srgbClr val="FFFFFF"/>
-                    </a:solidFill>
-                  </a:tcPr>
-                </a:tc>
-                <a:tc>
-                  <a:txBody>
-                    <a:bodyPr wrap="square"/>
-                    <a:lstStyle/>
-                    <a:p>
-                      <a:pPr algn="ctr"/>
-                      <a:r>
-                        <a:rPr sz="1100" b="0">
-                          <a:solidFill>
-                            <a:srgbClr val="000000"/>
-                          </a:solidFill>
-                          <a:latin typeface="Calibri"/>
-                        </a:rPr>
-                        <a:t>~1.85</a:t>
-                      </a:r>
-                    </a:p>
-                  </a:txBody>
-                  <a:tcPr>
-                    <a:solidFill>
-                      <a:srgbClr val="FFFFFF"/>
-                    </a:solidFill>
-                  </a:tcPr>
-                </a:tc>
-                <a:tc>
-                  <a:txBody>
-                    <a:bodyPr wrap="square"/>
-                    <a:lstStyle/>
-                    <a:p>
-                      <a:pPr algn="ctr"/>
-                      <a:r>
-                        <a:rPr sz="1100" b="0">
-                          <a:solidFill>
-                            <a:srgbClr val="000000"/>
-                          </a:solidFill>
-                          <a:latin typeface="Calibri"/>
-                        </a:rPr>
-                        <a:t>~1.88</a:t>
-                      </a:r>
-                    </a:p>
-                  </a:txBody>
-                  <a:tcPr>
-                    <a:solidFill>
-                      <a:srgbClr val="FFFFFF"/>
-                    </a:solidFill>
-                  </a:tcPr>
-                </a:tc>
-                <a:tc>
-                  <a:txBody>
-                    <a:bodyPr wrap="square"/>
-                    <a:lstStyle/>
-                    <a:p>
-                      <a:pPr algn="ctr"/>
-                      <a:r>
-                        <a:rPr sz="1100" b="0">
-                          <a:solidFill>
-                            <a:srgbClr val="000000"/>
-                          </a:solidFill>
-                          <a:latin typeface="Calibri"/>
-                        </a:rPr>
-                        <a:t>~1.16</a:t>
-                      </a:r>
-                    </a:p>
-                  </a:txBody>
-                  <a:tcPr>
-                    <a:solidFill>
-                      <a:srgbClr val="FFFFFF"/>
-                    </a:solidFill>
-                  </a:tcPr>
-                </a:tc>
-                <a:tc>
-                  <a:txBody>
-                    <a:bodyPr wrap="square"/>
-                    <a:lstStyle/>
-                    <a:p>
-                      <a:pPr algn="ctr"/>
-                      <a:r>
-                        <a:rPr sz="1100" b="0">
-                          <a:solidFill>
-                            <a:srgbClr val="000000"/>
-                          </a:solidFill>
-                          <a:latin typeface="Calibri"/>
-                        </a:rPr>
-                        <a:t>Very tight</a:t>
-                      </a:r>
-                    </a:p>
-                  </a:txBody>
-                  <a:tcPr>
-                    <a:solidFill>
-                      <a:srgbClr val="FFFFFF"/>
-                    </a:solidFill>
-                  </a:tcPr>
-                </a:tc>
-              </a:tr>
-            </a:tbl>
-          </a:graphicData>
-        </a:graphic>
-      </p:graphicFrame>
-      <p:sp>
-        <p:nvSpPr>
-          <p:cNvPr id="7" name="TextBox 6"/>
-          <p:cNvSpPr txBox="1"/>
-          <p:nvPr/>
-        </p:nvSpPr>
-        <p:spPr>
-          <a:xfrm>
-            <a:off x="350000" y="2870000"/>
-            <a:ext cx="9993400" cy="3200000"/>
-          </a:xfrm>
-          <a:prstGeom prst="rect">
-            <a:avLst/>
-          </a:prstGeom>
-          <a:noFill/>
-        </p:spPr>
-        <p:txBody>
-          <a:bodyPr wrap="square" anchor="t">
-            <a:spAutoFit/>
-          </a:bodyPr>
-          <a:lstStyle/>
-          <a:p>
-            <a:pPr algn="l">
-              <a:buNone/>
-            </a:pPr>
-            <a:r>
-              <a:rPr lang="en-US" sz="1400" b="1" dirty="0">
-                <a:solidFill>
-                  <a:srgbClr val="002060"/>
-                </a:solidFill>
-              </a:rPr>
-              <a:t>Key Findings</a:t>
-            </a:r>
-          </a:p>
-          <a:p>
-            <a:endParaRPr lang="en-US" sz="1100" dirty="0"/>
-          </a:p>
-          <a:p>
-            <a:pPr algn="l">
-              <a:buNone/>
-            </a:pPr>
-            <a:r>
-              <a:rPr lang="en-US" sz="1200" b="1" dirty="0">
-                <a:solidFill>
-                  <a:srgbClr val="002060"/>
-                </a:solidFill>
-              </a:rPr>
-              <a:t>Formation Resistivity Factor &amp; Resistivity Index:</a:t>
-            </a:r>
-          </a:p>
-          <a:p>
-            <a:pPr algn="l" marL="457200" indent="-457200">
-              <a:buChar char="•"/>
-            </a:pPr>
-            <a:r>
-              <a:rPr lang="en-US" sz="1200" dirty="0">
-                <a:solidFill>
-                  <a:srgbClr val="000000"/>
-                </a:solidFill>
-              </a:rPr>
-              <a:t>Average cementation exponent m = 1.84  (range: 1.83–1.85)</a:t>
-            </a:r>
-          </a:p>
-          <a:p>
-            <a:pPr algn="l" marL="457200" indent="-457200">
-              <a:buChar char="•"/>
-            </a:pPr>
-            <a:r>
-              <a:rPr lang="en-US" sz="1200" dirty="0">
-                <a:solidFill>
-                  <a:srgbClr val="000000"/>
-                </a:solidFill>
-              </a:rPr>
-              <a:t>Average saturation exponent n = 1.88  (range: 1.87–1.90)</a:t>
-            </a:r>
-          </a:p>
-          <a:p>
-            <a:endParaRPr lang="en-US" sz="1100" dirty="0"/>
-          </a:p>
-          <a:p>
-            <a:pPr algn="l">
-              <a:buNone/>
-            </a:pPr>
-            <a:r>
-              <a:rPr lang="en-US" sz="1200" b="1" dirty="0">
-                <a:solidFill>
-                  <a:srgbClr val="002060"/>
-                </a:solidFill>
-              </a:rPr>
-              <a:t>Cation Exchange Capacity (CEC):</a:t>
-            </a:r>
-          </a:p>
-          <a:p>
-            <a:pPr algn="l" marL="457200" indent="-457200">
-              <a:buChar char="•"/>
-            </a:pPr>
-            <a:r>
-              <a:rPr lang="en-US" sz="1200" dirty="0">
-                <a:solidFill>
-                  <a:srgbClr val="000000"/>
-                </a:solidFill>
-              </a:rPr>
-              <a:t>Range: 1.0800–1.1600 meq/100g  |  Average: 1.1150 meq/100g</a:t>
-            </a:r>
-          </a:p>
-          <a:p>
-            <a:endParaRPr lang="en-US" sz="1100" dirty="0"/>
-          </a:p>
-          <a:p>
-            <a:pPr algn="l">
-              <a:buNone/>
-            </a:pPr>
-            <a:r>
-              <a:rPr lang="en-US" sz="1200" b="1" dirty="0">
-                <a:solidFill>
-                  <a:srgbClr val="002060"/>
-                </a:solidFill>
-              </a:rPr>
-              <a:t>Air-Brine Capillary Pressure (Centrifuge):</a:t>
-            </a:r>
-          </a:p>
-          <a:p>
-            <a:pPr algn="l" marL="457200" indent="-457200">
-              <a:buChar char="•"/>
-            </a:pPr>
-            <a:r>
-              <a:rPr lang="en-US" sz="1200" dirty="0">
-                <a:solidFill>
-                  <a:srgbClr val="000000"/>
-                </a:solidFill>
-              </a:rPr>
-              <a:t>Sample at 3184 m: Swi = 83.7% PV at max drainage speed</a:t>
-            </a:r>
-          </a:p>
-          <a:p>
-            <a:pPr algn="l" marL="457200" indent="-457200">
-              <a:buChar char="✗"/>
-            </a:pPr>
-            <a:r>
-              <a:rPr lang="en-US" sz="1200" dirty="0">
-                <a:solidFill>
-                  <a:srgbClr val="000000"/>
-                </a:solidFill>
-              </a:rPr>
-              <a:t>Samples 3528, 3576, 3598.5 m: very tight — Swi measurements not obtainable</a:t>
-            </a:r>
-          </a:p>
-          <a:p>
-            <a:endParaRPr lang="en-US" sz="1100" dirty="0"/>
-          </a:p>
-          <a:p>
-            <a:pPr algn="l">
-              <a:buNone/>
-            </a:pPr>
-            <a:r>
-              <a:rPr lang="en-US" sz="1200" b="1" dirty="0">
-                <a:solidFill>
-                  <a:srgbClr val="002060"/>
-                </a:solidFill>
-              </a:rPr>
-              <a:t>Mercury Injection Capillary Pressure (MICP):</a:t>
-            </a:r>
-          </a:p>
-          <a:p>
-            <a:pPr algn="l" marL="457200" indent="-457200">
-              <a:buChar char="•"/>
-            </a:pPr>
-            <a:r>
-              <a:rPr lang="en-US" sz="1200" dirty="0">
-                <a:solidFill>
-                  <a:srgbClr val="000000"/>
-                </a:solidFill>
-              </a:rPr>
-              <a:t>Pore size distribution: macro 15.8%  |  meso 1.0%  |  micro 83.2%</a:t>
-            </a:r>
-          </a:p>
-          <a:p>
-            <a:pPr algn="l" marL="457200" indent="-457200">
-              <a:buChar char="•"/>
-            </a:pPr>
-            <a:r>
-              <a:rPr lang="en-US" sz="1200" dirty="0">
-                <a:solidFill>
-                  <a:srgbClr val="000000"/>
-                </a:solidFill>
-              </a:rPr>
-              <a:t>All 4 samples covered to max 2,000 psi</a:t>
-            </a:r>
-          </a:p>
-        </p:txBody>
-      </p:sp>
-    </p:spTree>
-  </p:cSld>
-  <p:clrMapOvr>
-    <a:masterClrMapping/>
-  </p:clrMapOvr>
-</p:sld>
-</file>
-
-<file path=ppt/slides/slide25.xml><?xml version="1.0" encoding="utf-8"?>
 <p:sld xmlns:a="http://schemas.openxmlformats.org/drawingml/2006/main" xmlns:p="http://schemas.openxmlformats.org/presentationml/2006/main" xmlns:r="http://schemas.openxmlformats.org/officeDocument/2006/relationships">
   <p:cSld>
     <p:spTree>
@@ -17981,7 +16818,7 @@
                   <a:srgbClr val="595959"/>
                 </a:solidFill>
               </a:rPr>
-              <a:t>Document: RELATIVE PERMEABILITY NUMERICAL INTERPRETATION (MDC Oil &amp; Gas SK320 / Senergy International, Nov 2015)  |  49 pages extracted</a:t>
+              <a:t>Document: RELATIVE PERMEABILITY NUMERICAL INTERPRETATION  (MDC Oil &amp; Gas SK320 / Senergy International, Nov 2015)  |  49 pages extracted</a:t>
             </a:r>
           </a:p>
         </p:txBody>
@@ -18005,10 +16842,10 @@
                 <a:tableStyleId>{5C22544A-7EE6-4342-B048-85BDC9FD1C3A}</a:tableStyleId>
               </a:tblPr>
               <a:tblGrid>
-                <a:gridCol w="999340"/>
-                <a:gridCol w="1598944"/>
+                <a:gridCol w="799472"/>
+                <a:gridCol w="1399076"/>
                 <a:gridCol w="1199208"/>
-                <a:gridCol w="6195908"/>
+                <a:gridCol w="6595644"/>
               </a:tblGrid>
               <a:tr h="194439">
                 <a:tc>
@@ -18047,7 +16884,7 @@
                           </a:solidFill>
                           <a:latin typeface="Calibri"/>
                         </a:rPr>
-                        <a:t>Duration (s)</a:t>
+                        <a:t>Duration</a:t>
                       </a:r>
                     </a:p>
                   </a:txBody>
@@ -18141,7 +16978,7 @@
                           </a:solidFill>
                           <a:latin typeface="Calibri"/>
                         </a:rPr>
-                        <a:t>500.2</a:t>
+                        <a:t>8.3 min</a:t>
                       </a:r>
                     </a:p>
                   </a:txBody>
@@ -18235,7 +17072,7 @@
                           </a:solidFill>
                           <a:latin typeface="Calibri"/>
                         </a:rPr>
-                        <a:t>346.1</a:t>
+                        <a:t>5.8 min</a:t>
                       </a:r>
                     </a:p>
                   </a:txBody>
@@ -18329,7 +17166,7 @@
                           </a:solidFill>
                           <a:latin typeface="Calibri"/>
                         </a:rPr>
-                        <a:t>531.1</a:t>
+                        <a:t>8.9 min</a:t>
                       </a:r>
                     </a:p>
                   </a:txBody>
@@ -18423,7 +17260,7 @@
                           </a:solidFill>
                           <a:latin typeface="Calibri"/>
                         </a:rPr>
-                        <a:t>757.7</a:t>
+                        <a:t>12.6 min</a:t>
                       </a:r>
                     </a:p>
                   </a:txBody>
@@ -18517,7 +17354,7 @@
                           </a:solidFill>
                           <a:latin typeface="Calibri"/>
                         </a:rPr>
-                        <a:t>1,398.2</a:t>
+                        <a:t>23.3 min</a:t>
                       </a:r>
                     </a:p>
                   </a:txBody>
@@ -18611,7 +17448,7 @@
                           </a:solidFill>
                           <a:latin typeface="Calibri"/>
                         </a:rPr>
-                        <a:t>1,616.7</a:t>
+                        <a:t>26.9 min</a:t>
                       </a:r>
                     </a:p>
                   </a:txBody>
@@ -18705,7 +17542,7 @@
                           </a:solidFill>
                           <a:latin typeface="Calibri"/>
                         </a:rPr>
-                        <a:t>2,721.4</a:t>
+                        <a:t>45.4 min</a:t>
                       </a:r>
                     </a:p>
                   </a:txBody>
@@ -18799,7 +17636,7 @@
                           </a:solidFill>
                           <a:latin typeface="Calibri"/>
                         </a:rPr>
-                        <a:t>547.0</a:t>
+                        <a:t>9.1 min</a:t>
                       </a:r>
                     </a:p>
                   </a:txBody>
@@ -18893,7 +17730,7 @@
                           </a:solidFill>
                           <a:latin typeface="Calibri"/>
                         </a:rPr>
-                        <a:t>2,812.0</a:t>
+                        <a:t>46.9 min</a:t>
                       </a:r>
                     </a:p>
                   </a:txBody>
@@ -18987,7 +17824,7 @@
                           </a:solidFill>
                           <a:latin typeface="Calibri"/>
                         </a:rPr>
-                        <a:t>1,514.9</a:t>
+                        <a:t>25.2 min</a:t>
                       </a:r>
                     </a:p>
                   </a:txBody>
@@ -19081,7 +17918,7 @@
                           </a:solidFill>
                           <a:latin typeface="Calibri"/>
                         </a:rPr>
-                        <a:t>527.0</a:t>
+                        <a:t>8.8 min</a:t>
                       </a:r>
                     </a:p>
                   </a:txBody>
@@ -19175,7 +18012,7 @@
                           </a:solidFill>
                           <a:latin typeface="Calibri"/>
                         </a:rPr>
-                        <a:t>888.1</a:t>
+                        <a:t>14.8 min</a:t>
                       </a:r>
                     </a:p>
                   </a:txBody>
@@ -19269,7 +18106,7 @@
                           </a:solidFill>
                           <a:latin typeface="Calibri"/>
                         </a:rPr>
-                        <a:t>1,567.7</a:t>
+                        <a:t>26.1 min</a:t>
                       </a:r>
                     </a:p>
                   </a:txBody>
@@ -19363,7 +18200,7 @@
                           </a:solidFill>
                           <a:latin typeface="Calibri"/>
                         </a:rPr>
-                        <a:t>3,781.8</a:t>
+                        <a:t>1.1 hrs</a:t>
                       </a:r>
                     </a:p>
                   </a:txBody>
@@ -19457,7 +18294,7 @@
                           </a:solidFill>
                           <a:latin typeface="Calibri"/>
                         </a:rPr>
-                        <a:t>37,705.4</a:t>
+                        <a:t>10.5 hrs</a:t>
                       </a:r>
                     </a:p>
                   </a:txBody>
@@ -19551,7 +18388,7 @@
                           </a:solidFill>
                           <a:latin typeface="Calibri"/>
                         </a:rPr>
-                        <a:t>9,000.6</a:t>
+                        <a:t>2.5 hrs</a:t>
                       </a:r>
                     </a:p>
                   </a:txBody>
@@ -19645,7 +18482,7 @@
                           </a:solidFill>
                           <a:latin typeface="Calibri"/>
                         </a:rPr>
-                        <a:t>1,473.6</a:t>
+                        <a:t>24.6 min</a:t>
                       </a:r>
                     </a:p>
                   </a:txBody>
@@ -19739,7 +18576,7 @@
                           </a:solidFill>
                           <a:latin typeface="Calibri"/>
                         </a:rPr>
-                        <a:t>941.2</a:t>
+                        <a:t>15.7 min</a:t>
                       </a:r>
                     </a:p>
                   </a:txBody>
@@ -19833,7 +18670,7 @@
                           </a:solidFill>
                           <a:latin typeface="Calibri"/>
                         </a:rPr>
-                        <a:t>1,103.5</a:t>
+                        <a:t>18.4 min</a:t>
                       </a:r>
                     </a:p>
                   </a:txBody>
@@ -19927,7 +18764,7 @@
                           </a:solidFill>
                           <a:latin typeface="Calibri"/>
                         </a:rPr>
-                        <a:t>419.6</a:t>
+                        <a:t>7.0 min</a:t>
                       </a:r>
                     </a:p>
                   </a:txBody>
@@ -20021,7 +18858,7 @@
                           </a:solidFill>
                           <a:latin typeface="Calibri"/>
                         </a:rPr>
-                        <a:t>4,557.5</a:t>
+                        <a:t>1.3 hrs</a:t>
                       </a:r>
                     </a:p>
                   </a:txBody>
@@ -20115,7 +18952,7 @@
                           </a:solidFill>
                           <a:latin typeface="Calibri"/>
                         </a:rPr>
-                        <a:t>8,342.0</a:t>
+                        <a:t>2.3 hrs</a:t>
                       </a:r>
                     </a:p>
                   </a:txBody>
@@ -20209,7 +19046,7 @@
                           </a:solidFill>
                           <a:latin typeface="Calibri"/>
                         </a:rPr>
-                        <a:t>9,978.8</a:t>
+                        <a:t>2.8 hrs</a:t>
                       </a:r>
                     </a:p>
                   </a:txBody>
@@ -20303,7 +19140,7 @@
                           </a:solidFill>
                           <a:latin typeface="Calibri"/>
                         </a:rPr>
-                        <a:t>1,507.1</a:t>
+                        <a:t>25.1 min</a:t>
                       </a:r>
                     </a:p>
                   </a:txBody>
@@ -20374,30 +19211,30 @@
                           </a:solidFill>
                           <a:latin typeface="Calibri"/>
                         </a:rPr>
-                        <a:t>25-34</a:t>
-                      </a:r>
-                    </a:p>
-                  </a:txBody>
-                  <a:tcPr>
-                    <a:solidFill>
-                      <a:srgbClr val="F2F2F2"/>
-                    </a:solidFill>
-                  </a:tcPr>
-                </a:tc>
-                <a:tc>
-                  <a:txBody>
-                    <a:bodyPr wrap="square"/>
-                    <a:lstStyle/>
-                    <a:p>
-                      <a:pPr algn="ctr"/>
-                      <a:r>
-                        <a:rPr sz="1000" b="0">
-                          <a:solidFill>
-                            <a:srgbClr val="000000"/>
-                          </a:solidFill>
-                          <a:latin typeface="Calibri"/>
-                        </a:rPr>
-                        <a:t>~7,386.2</a:t>
+                        <a:t>25–34</a:t>
+                      </a:r>
+                    </a:p>
+                  </a:txBody>
+                  <a:tcPr>
+                    <a:solidFill>
+                      <a:srgbClr val="F2F2F2"/>
+                    </a:solidFill>
+                  </a:tcPr>
+                </a:tc>
+                <a:tc>
+                  <a:txBody>
+                    <a:bodyPr wrap="square"/>
+                    <a:lstStyle/>
+                    <a:p>
+                      <a:pPr algn="ctr"/>
+                      <a:r>
+                        <a:rPr sz="1000" b="0">
+                          <a:solidFill>
+                            <a:srgbClr val="000000"/>
+                          </a:solidFill>
+                          <a:latin typeface="Calibri"/>
+                        </a:rPr>
+                        <a:t>~2.1 hrs</a:t>
                       </a:r>
                     </a:p>
                   </a:txBody>
@@ -20443,7 +19280,7 @@
                           </a:solidFill>
                           <a:latin typeface="Calibri"/>
                         </a:rPr>
-                        <a:t>Samples 2-033 (pp.25-34)</a:t>
+                        <a:t>Samples 2-033 (pp.25–34)</a:t>
                       </a:r>
                     </a:p>
                   </a:txBody>
@@ -20491,7 +19328,7 @@
                           </a:solidFill>
                           <a:latin typeface="Calibri"/>
                         </a:rPr>
-                        <a:t>8,521.5</a:t>
+                        <a:t>2.4 hrs</a:t>
                       </a:r>
                     </a:p>
                   </a:txBody>
@@ -20585,7 +19422,7 @@
                           </a:solidFill>
                           <a:latin typeface="Calibri"/>
                         </a:rPr>
-                        <a:t>9,760.7</a:t>
+                        <a:t>2.7 hrs</a:t>
                       </a:r>
                     </a:p>
                   </a:txBody>
@@ -20679,7 +19516,7 @@
                           </a:solidFill>
                           <a:latin typeface="Calibri"/>
                         </a:rPr>
-                        <a:t>6,897.0</a:t>
+                        <a:t>1.9 hrs</a:t>
                       </a:r>
                     </a:p>
                   </a:txBody>
@@ -20750,30 +19587,30 @@
                           </a:solidFill>
                           <a:latin typeface="Calibri"/>
                         </a:rPr>
-                        <a:t>38-42</a:t>
-                      </a:r>
-                    </a:p>
-                  </a:txBody>
-                  <a:tcPr>
-                    <a:solidFill>
-                      <a:srgbClr val="F2F2F2"/>
-                    </a:solidFill>
-                  </a:tcPr>
-                </a:tc>
-                <a:tc>
-                  <a:txBody>
-                    <a:bodyPr wrap="square"/>
-                    <a:lstStyle/>
-                    <a:p>
-                      <a:pPr algn="ctr"/>
-                      <a:r>
-                        <a:rPr sz="1000" b="0">
-                          <a:solidFill>
-                            <a:srgbClr val="000000"/>
-                          </a:solidFill>
-                          <a:latin typeface="Calibri"/>
-                        </a:rPr>
-                        <a:t>~3,317.0</a:t>
+                        <a:t>38–42</a:t>
+                      </a:r>
+                    </a:p>
+                  </a:txBody>
+                  <a:tcPr>
+                    <a:solidFill>
+                      <a:srgbClr val="F2F2F2"/>
+                    </a:solidFill>
+                  </a:tcPr>
+                </a:tc>
+                <a:tc>
+                  <a:txBody>
+                    <a:bodyPr wrap="square"/>
+                    <a:lstStyle/>
+                    <a:p>
+                      <a:pPr algn="ctr"/>
+                      <a:r>
+                        <a:rPr sz="1000" b="0">
+                          <a:solidFill>
+                            <a:srgbClr val="000000"/>
+                          </a:solidFill>
+                          <a:latin typeface="Calibri"/>
+                        </a:rPr>
+                        <a:t>~55.3 min</a:t>
                       </a:r>
                     </a:p>
                   </a:txBody>
@@ -20867,7 +19704,7 @@
                           </a:solidFill>
                           <a:latin typeface="Calibri"/>
                         </a:rPr>
-                        <a:t>9,061.9</a:t>
+                        <a:t>2.5 hrs</a:t>
                       </a:r>
                     </a:p>
                   </a:txBody>
@@ -20961,7 +19798,7 @@
                           </a:solidFill>
                           <a:latin typeface="Calibri"/>
                         </a:rPr>
-                        <a:t>9,157.9</a:t>
+                        <a:t>2.5 hrs</a:t>
                       </a:r>
                     </a:p>
                   </a:txBody>
@@ -21032,30 +19869,30 @@
                           </a:solidFill>
                           <a:latin typeface="Calibri"/>
                         </a:rPr>
-                        <a:t>45-49</a:t>
-                      </a:r>
-                    </a:p>
-                  </a:txBody>
-                  <a:tcPr>
-                    <a:solidFill>
-                      <a:srgbClr val="FFFFFF"/>
-                    </a:solidFill>
-                  </a:tcPr>
-                </a:tc>
-                <a:tc>
-                  <a:txBody>
-                    <a:bodyPr wrap="square"/>
-                    <a:lstStyle/>
-                    <a:p>
-                      <a:pPr algn="ctr"/>
-                      <a:r>
-                        <a:rPr sz="1000" b="0">
-                          <a:solidFill>
-                            <a:srgbClr val="000000"/>
-                          </a:solidFill>
-                          <a:latin typeface="Calibri"/>
-                        </a:rPr>
-                        <a:t>~5,084.5</a:t>
+                        <a:t>45–49</a:t>
+                      </a:r>
+                    </a:p>
+                  </a:txBody>
+                  <a:tcPr>
+                    <a:solidFill>
+                      <a:srgbClr val="FFFFFF"/>
+                    </a:solidFill>
+                  </a:tcPr>
+                </a:tc>
+                <a:tc>
+                  <a:txBody>
+                    <a:bodyPr wrap="square"/>
+                    <a:lstStyle/>
+                    <a:p>
+                      <a:pPr algn="ctr"/>
+                      <a:r>
+                        <a:rPr sz="1000" b="0">
+                          <a:solidFill>
+                            <a:srgbClr val="000000"/>
+                          </a:solidFill>
+                          <a:latin typeface="Calibri"/>
+                        </a:rPr>
+                        <a:t>~1.4 hrs</a:t>
                       </a:r>
                     </a:p>
                   </a:txBody>
@@ -21147,7 +19984,7 @@
                   <a:srgbClr val="595959"/>
                 </a:solidFill>
               </a:rPr>
-              <a:t>TOTAL:  49 pages  |  176,782.4 s (~49.1 hrs)  |  122,934 tokens  |  5 samples (depths 2511–2516 m)  |  Page 15 alone: 37,705 s (10.5 hrs!) — largest single-page extraction in this benchmark</a:t>
+              <a:t>TOTAL:  49 pages  |  49.1 hrs  |  122,934 tokens  |  5 samples (depths 2511–2516 m)  |  Page 15 alone: 10.5 hrs — largest single-page extraction in this benchmark</a:t>
             </a:r>
           </a:p>
         </p:txBody>
@@ -21160,1202 +19997,7 @@
 </p:sld>
 </file>
 
-<file path=ppt/slides/slide26.xml><?xml version="1.0" encoding="utf-8"?>
-<p:sld xmlns:a="http://schemas.openxmlformats.org/drawingml/2006/main" xmlns:p="http://schemas.openxmlformats.org/presentationml/2006/main" xmlns:r="http://schemas.openxmlformats.org/officeDocument/2006/relationships">
-  <p:cSld>
-    <p:spTree>
-      <p:nvGrpSpPr>
-        <p:cNvPr id="1" name=""/>
-        <p:cNvGrpSpPr/>
-        <p:nvPr/>
-      </p:nvGrpSpPr>
-      <p:grpSpPr/>
-      <p:sp>
-        <p:nvSpPr>
-          <p:cNvPr id="2" name="Title 1"/>
-          <p:cNvSpPr>
-            <a:spLocks noGrp="1"/>
-          </p:cNvSpPr>
-          <p:nvPr>
-            <p:ph type="title"/>
-          </p:nvPr>
-        </p:nvSpPr>
-        <p:spPr/>
-        <p:txBody>
-          <a:bodyPr/>
-          <a:lstStyle/>
-          <a:p/>
-        </p:txBody>
-      </p:sp>
-      <p:sp>
-        <p:nvSpPr>
-          <p:cNvPr id="3" name="Text Placeholder 2"/>
-          <p:cNvSpPr>
-            <a:spLocks noGrp="1"/>
-          </p:cNvSpPr>
-          <p:nvPr>
-            <p:ph type="body" idx="1"/>
-          </p:nvPr>
-        </p:nvSpPr>
-        <p:spPr/>
-        <p:txBody>
-          <a:bodyPr/>
-          <a:lstStyle/>
-          <a:p/>
-        </p:txBody>
-      </p:sp>
-      <p:sp>
-        <p:nvSpPr>
-          <p:cNvPr id="4" name="TextBox 3"/>
-          <p:cNvSpPr txBox="1"/>
-          <p:nvPr/>
-        </p:nvSpPr>
-        <p:spPr>
-          <a:xfrm>
-            <a:off x="350000" y="80000"/>
-            <a:ext cx="9993400" cy="480000"/>
-          </a:xfrm>
-          <a:prstGeom prst="rect">
-            <a:avLst/>
-          </a:prstGeom>
-          <a:noFill/>
-        </p:spPr>
-        <p:txBody>
-          <a:bodyPr wrap="square" anchor="t">
-            <a:spAutoFit/>
-          </a:bodyPr>
-          <a:lstStyle/>
-          <a:p>
-            <a:pPr algn="l">
-              <a:buNone/>
-            </a:pPr>
-            <a:r>
-              <a:rPr lang="en-US" sz="2200" b="1" dirty="0">
-                <a:solidFill>
-                  <a:srgbClr val="002060"/>
-                </a:solidFill>
-              </a:rPr>
-              <a:t>Pegaga-2 — Sample Properties &amp; Relative Permeability</a:t>
-            </a:r>
-          </a:p>
-        </p:txBody>
-      </p:sp>
-      <p:sp>
-        <p:nvSpPr>
-          <p:cNvPr id="5" name="TextBox 4"/>
-          <p:cNvSpPr txBox="1"/>
-          <p:nvPr/>
-        </p:nvSpPr>
-        <p:spPr>
-          <a:xfrm>
-            <a:off x="350000" y="590000"/>
-            <a:ext cx="9993400" cy="280000"/>
-          </a:xfrm>
-          <a:prstGeom prst="rect">
-            <a:avLst/>
-          </a:prstGeom>
-          <a:noFill/>
-        </p:spPr>
-        <p:txBody>
-          <a:bodyPr wrap="square" anchor="t">
-            <a:spAutoFit/>
-          </a:bodyPr>
-          <a:lstStyle/>
-          <a:p>
-            <a:pPr algn="l">
-              <a:buNone/>
-            </a:pPr>
-            <a:r>
-              <a:rPr lang="en-US" sz="1200" dirty="0">
-                <a:solidFill>
-                  <a:srgbClr val="595959"/>
-                </a:solidFill>
-              </a:rPr>
-              <a:t>5 samples tested using hybrid USS Kr gas-water drainage + imbibition centrifuge  |  Interpreted using Sendra™ coreflood simulator</a:t>
-            </a:r>
-          </a:p>
-        </p:txBody>
-      </p:sp>
-      <p:graphicFrame>
-        <p:nvGraphicFramePr>
-          <p:cNvPr id="6" name="Table 5"/>
-          <p:cNvGraphicFramePr>
-            <a:graphicFrameLocks noGrp="1"/>
-          </p:cNvGraphicFramePr>
-          <p:nvPr/>
-        </p:nvGraphicFramePr>
-        <p:xfrm>
-          <a:off x="350000" y="920000"/>
-          <a:ext cx="9993400" cy="1700000"/>
-        </p:xfrm>
-        <a:graphic>
-          <a:graphicData uri="http://schemas.openxmlformats.org/drawingml/2006/table">
-            <a:tbl>
-              <a:tblPr firstRow="1" bandRow="1">
-                <a:tableStyleId>{5C22544A-7EE6-4342-B048-85BDC9FD1C3A}</a:tableStyleId>
-              </a:tblPr>
-              <a:tblGrid>
-                <a:gridCol w="1399076"/>
-                <a:gridCol w="1399076"/>
-                <a:gridCol w="1399076"/>
-                <a:gridCol w="1399076"/>
-                <a:gridCol w="2198548"/>
-                <a:gridCol w="2198548"/>
-              </a:tblGrid>
-              <a:tr h="283333">
-                <a:tc>
-                  <a:txBody>
-                    <a:bodyPr wrap="square"/>
-                    <a:lstStyle/>
-                    <a:p>
-                      <a:pPr algn="ctr"/>
-                      <a:r>
-                        <a:rPr sz="1300" b="1">
-                          <a:solidFill>
-                            <a:srgbClr val="FFFFFF"/>
-                          </a:solidFill>
-                          <a:latin typeface="Calibri"/>
-                        </a:rPr>
-                        <a:t>Sample ID</a:t>
-                      </a:r>
-                    </a:p>
-                  </a:txBody>
-                  <a:tcPr>
-                    <a:solidFill>
-                      <a:srgbClr val="002060"/>
-                    </a:solidFill>
-                  </a:tcPr>
-                </a:tc>
-                <a:tc>
-                  <a:txBody>
-                    <a:bodyPr wrap="square"/>
-                    <a:lstStyle/>
-                    <a:p>
-                      <a:pPr algn="ctr"/>
-                      <a:r>
-                        <a:rPr sz="1300" b="1">
-                          <a:solidFill>
-                            <a:srgbClr val="FFFFFF"/>
-                          </a:solidFill>
-                          <a:latin typeface="Calibri"/>
-                        </a:rPr>
-                        <a:t>Depth (m)</a:t>
-                      </a:r>
-                    </a:p>
-                  </a:txBody>
-                  <a:tcPr>
-                    <a:solidFill>
-                      <a:srgbClr val="002060"/>
-                    </a:solidFill>
-                  </a:tcPr>
-                </a:tc>
-                <a:tc>
-                  <a:txBody>
-                    <a:bodyPr wrap="square"/>
-                    <a:lstStyle/>
-                    <a:p>
-                      <a:pPr algn="ctr"/>
-                      <a:r>
-                        <a:rPr sz="1300" b="1">
-                          <a:solidFill>
-                            <a:srgbClr val="FFFFFF"/>
-                          </a:solidFill>
-                          <a:latin typeface="Calibri"/>
-                        </a:rPr>
-                        <a:t>Ka (mD) NCS</a:t>
-                      </a:r>
-                    </a:p>
-                  </a:txBody>
-                  <a:tcPr>
-                    <a:solidFill>
-                      <a:srgbClr val="002060"/>
-                    </a:solidFill>
-                  </a:tcPr>
-                </a:tc>
-                <a:tc>
-                  <a:txBody>
-                    <a:bodyPr wrap="square"/>
-                    <a:lstStyle/>
-                    <a:p>
-                      <a:pPr algn="ctr"/>
-                      <a:r>
-                        <a:rPr sz="1300" b="1">
-                          <a:solidFill>
-                            <a:srgbClr val="FFFFFF"/>
-                          </a:solidFill>
-                          <a:latin typeface="Calibri"/>
-                        </a:rPr>
-                        <a:t>Porosity (%)</a:t>
-                      </a:r>
-                    </a:p>
-                  </a:txBody>
-                  <a:tcPr>
-                    <a:solidFill>
-                      <a:srgbClr val="002060"/>
-                    </a:solidFill>
-                  </a:tcPr>
-                </a:tc>
-                <a:tc>
-                  <a:txBody>
-                    <a:bodyPr wrap="square"/>
-                    <a:lstStyle/>
-                    <a:p>
-                      <a:pPr algn="ctr"/>
-                      <a:r>
-                        <a:rPr sz="1300" b="1">
-                          <a:solidFill>
-                            <a:srgbClr val="FFFFFF"/>
-                          </a:solidFill>
-                          <a:latin typeface="Calibri"/>
-                        </a:rPr>
-                        <a:t>Target Swi (%)</a:t>
-                      </a:r>
-                    </a:p>
-                  </a:txBody>
-                  <a:tcPr>
-                    <a:solidFill>
-                      <a:srgbClr val="002060"/>
-                    </a:solidFill>
-                  </a:tcPr>
-                </a:tc>
-                <a:tc>
-                  <a:txBody>
-                    <a:bodyPr wrap="square"/>
-                    <a:lstStyle/>
-                    <a:p>
-                      <a:pPr algn="ctr"/>
-                      <a:r>
-                        <a:rPr sz="1300" b="1">
-                          <a:solidFill>
-                            <a:srgbClr val="FFFFFF"/>
-                          </a:solidFill>
-                          <a:latin typeface="Calibri"/>
-                        </a:rPr>
-                        <a:t>Achieved Swi (%)</a:t>
-                      </a:r>
-                    </a:p>
-                  </a:txBody>
-                  <a:tcPr>
-                    <a:solidFill>
-                      <a:srgbClr val="002060"/>
-                    </a:solidFill>
-                  </a:tcPr>
-                </a:tc>
-              </a:tr>
-              <a:tr h="283333">
-                <a:tc>
-                  <a:txBody>
-                    <a:bodyPr wrap="square"/>
-                    <a:lstStyle/>
-                    <a:p>
-                      <a:pPr algn="l"/>
-                      <a:r>
-                        <a:rPr sz="1200" b="0">
-                          <a:solidFill>
-                            <a:srgbClr val="000000"/>
-                          </a:solidFill>
-                          <a:latin typeface="Calibri"/>
-                        </a:rPr>
-                        <a:t>2-015</a:t>
-                      </a:r>
-                    </a:p>
-                  </a:txBody>
-                  <a:tcPr>
-                    <a:solidFill>
-                      <a:srgbClr val="F2F2F2"/>
-                    </a:solidFill>
-                  </a:tcPr>
-                </a:tc>
-                <a:tc>
-                  <a:txBody>
-                    <a:bodyPr wrap="square"/>
-                    <a:lstStyle/>
-                    <a:p>
-                      <a:pPr algn="ctr"/>
-                      <a:r>
-                        <a:rPr sz="1200" b="0">
-                          <a:solidFill>
-                            <a:srgbClr val="000000"/>
-                          </a:solidFill>
-                          <a:latin typeface="Calibri"/>
-                        </a:rPr>
-                        <a:t>2511.1</a:t>
-                      </a:r>
-                    </a:p>
-                  </a:txBody>
-                  <a:tcPr>
-                    <a:solidFill>
-                      <a:srgbClr val="F2F2F2"/>
-                    </a:solidFill>
-                  </a:tcPr>
-                </a:tc>
-                <a:tc>
-                  <a:txBody>
-                    <a:bodyPr wrap="square"/>
-                    <a:lstStyle/>
-                    <a:p>
-                      <a:pPr algn="ctr"/>
-                      <a:r>
-                        <a:rPr sz="1200" b="0">
-                          <a:solidFill>
-                            <a:srgbClr val="000000"/>
-                          </a:solidFill>
-                          <a:latin typeface="Calibri"/>
-                        </a:rPr>
-                        <a:t>2.46</a:t>
-                      </a:r>
-                    </a:p>
-                  </a:txBody>
-                  <a:tcPr>
-                    <a:solidFill>
-                      <a:srgbClr val="F2F2F2"/>
-                    </a:solidFill>
-                  </a:tcPr>
-                </a:tc>
-                <a:tc>
-                  <a:txBody>
-                    <a:bodyPr wrap="square"/>
-                    <a:lstStyle/>
-                    <a:p>
-                      <a:pPr algn="ctr"/>
-                      <a:r>
-                        <a:rPr sz="1200" b="0">
-                          <a:solidFill>
-                            <a:srgbClr val="000000"/>
-                          </a:solidFill>
-                          <a:latin typeface="Calibri"/>
-                        </a:rPr>
-                        <a:t>18.6</a:t>
-                      </a:r>
-                    </a:p>
-                  </a:txBody>
-                  <a:tcPr>
-                    <a:solidFill>
-                      <a:srgbClr val="F2F2F2"/>
-                    </a:solidFill>
-                  </a:tcPr>
-                </a:tc>
-                <a:tc>
-                  <a:txBody>
-                    <a:bodyPr wrap="square"/>
-                    <a:lstStyle/>
-                    <a:p>
-                      <a:pPr algn="ctr"/>
-                      <a:r>
-                        <a:rPr sz="1200" b="0">
-                          <a:solidFill>
-                            <a:srgbClr val="000000"/>
-                          </a:solidFill>
-                          <a:latin typeface="Calibri"/>
-                        </a:rPr>
-                        <a:t>20</a:t>
-                      </a:r>
-                    </a:p>
-                  </a:txBody>
-                  <a:tcPr>
-                    <a:solidFill>
-                      <a:srgbClr val="F2F2F2"/>
-                    </a:solidFill>
-                  </a:tcPr>
-                </a:tc>
-                <a:tc>
-                  <a:txBody>
-                    <a:bodyPr wrap="square"/>
-                    <a:lstStyle/>
-                    <a:p>
-                      <a:pPr algn="ctr"/>
-                      <a:r>
-                        <a:rPr sz="1200" b="0">
-                          <a:solidFill>
-                            <a:srgbClr val="000000"/>
-                          </a:solidFill>
-                          <a:latin typeface="Calibri"/>
-                        </a:rPr>
-                        <a:t>20.5</a:t>
-                      </a:r>
-                    </a:p>
-                  </a:txBody>
-                  <a:tcPr>
-                    <a:solidFill>
-                      <a:srgbClr val="F2F2F2"/>
-                    </a:solidFill>
-                  </a:tcPr>
-                </a:tc>
-              </a:tr>
-              <a:tr h="283333">
-                <a:tc>
-                  <a:txBody>
-                    <a:bodyPr wrap="square"/>
-                    <a:lstStyle/>
-                    <a:p>
-                      <a:pPr algn="l"/>
-                      <a:r>
-                        <a:rPr sz="1200" b="0">
-                          <a:solidFill>
-                            <a:srgbClr val="000000"/>
-                          </a:solidFill>
-                          <a:latin typeface="Calibri"/>
-                        </a:rPr>
-                        <a:t>2-019</a:t>
-                      </a:r>
-                    </a:p>
-                  </a:txBody>
-                  <a:tcPr>
-                    <a:solidFill>
-                      <a:srgbClr val="FFFFFF"/>
-                    </a:solidFill>
-                  </a:tcPr>
-                </a:tc>
-                <a:tc>
-                  <a:txBody>
-                    <a:bodyPr wrap="square"/>
-                    <a:lstStyle/>
-                    <a:p>
-                      <a:pPr algn="ctr"/>
-                      <a:r>
-                        <a:rPr sz="1200" b="0">
-                          <a:solidFill>
-                            <a:srgbClr val="000000"/>
-                          </a:solidFill>
-                          <a:latin typeface="Calibri"/>
-                        </a:rPr>
-                        <a:t>2512.2</a:t>
-                      </a:r>
-                    </a:p>
-                  </a:txBody>
-                  <a:tcPr>
-                    <a:solidFill>
-                      <a:srgbClr val="FFFFFF"/>
-                    </a:solidFill>
-                  </a:tcPr>
-                </a:tc>
-                <a:tc>
-                  <a:txBody>
-                    <a:bodyPr wrap="square"/>
-                    <a:lstStyle/>
-                    <a:p>
-                      <a:pPr algn="ctr"/>
-                      <a:r>
-                        <a:rPr sz="1200" b="0">
-                          <a:solidFill>
-                            <a:srgbClr val="000000"/>
-                          </a:solidFill>
-                          <a:latin typeface="Calibri"/>
-                        </a:rPr>
-                        <a:t>37.0</a:t>
-                      </a:r>
-                    </a:p>
-                  </a:txBody>
-                  <a:tcPr>
-                    <a:solidFill>
-                      <a:srgbClr val="FFFFFF"/>
-                    </a:solidFill>
-                  </a:tcPr>
-                </a:tc>
-                <a:tc>
-                  <a:txBody>
-                    <a:bodyPr wrap="square"/>
-                    <a:lstStyle/>
-                    <a:p>
-                      <a:pPr algn="ctr"/>
-                      <a:r>
-                        <a:rPr sz="1200" b="0">
-                          <a:solidFill>
-                            <a:srgbClr val="000000"/>
-                          </a:solidFill>
-                          <a:latin typeface="Calibri"/>
-                        </a:rPr>
-                        <a:t>24.5</a:t>
-                      </a:r>
-                    </a:p>
-                  </a:txBody>
-                  <a:tcPr>
-                    <a:solidFill>
-                      <a:srgbClr val="FFFFFF"/>
-                    </a:solidFill>
-                  </a:tcPr>
-                </a:tc>
-                <a:tc>
-                  <a:txBody>
-                    <a:bodyPr wrap="square"/>
-                    <a:lstStyle/>
-                    <a:p>
-                      <a:pPr algn="ctr"/>
-                      <a:r>
-                        <a:rPr sz="1200" b="0">
-                          <a:solidFill>
-                            <a:srgbClr val="000000"/>
-                          </a:solidFill>
-                          <a:latin typeface="Calibri"/>
-                        </a:rPr>
-                        <a:t>7.5</a:t>
-                      </a:r>
-                    </a:p>
-                  </a:txBody>
-                  <a:tcPr>
-                    <a:solidFill>
-                      <a:srgbClr val="FFFFFF"/>
-                    </a:solidFill>
-                  </a:tcPr>
-                </a:tc>
-                <a:tc>
-                  <a:txBody>
-                    <a:bodyPr wrap="square"/>
-                    <a:lstStyle/>
-                    <a:p>
-                      <a:pPr algn="ctr"/>
-                      <a:r>
-                        <a:rPr sz="1200" b="0">
-                          <a:solidFill>
-                            <a:srgbClr val="000000"/>
-                          </a:solidFill>
-                          <a:latin typeface="Calibri"/>
-                        </a:rPr>
-                        <a:t>9.2</a:t>
-                      </a:r>
-                    </a:p>
-                  </a:txBody>
-                  <a:tcPr>
-                    <a:solidFill>
-                      <a:srgbClr val="FFFFFF"/>
-                    </a:solidFill>
-                  </a:tcPr>
-                </a:tc>
-              </a:tr>
-              <a:tr h="283333">
-                <a:tc>
-                  <a:txBody>
-                    <a:bodyPr wrap="square"/>
-                    <a:lstStyle/>
-                    <a:p>
-                      <a:pPr algn="l"/>
-                      <a:r>
-                        <a:rPr sz="1200" b="0">
-                          <a:solidFill>
-                            <a:srgbClr val="000000"/>
-                          </a:solidFill>
-                          <a:latin typeface="Calibri"/>
-                        </a:rPr>
-                        <a:t>2-023</a:t>
-                      </a:r>
-                    </a:p>
-                  </a:txBody>
-                  <a:tcPr>
-                    <a:solidFill>
-                      <a:srgbClr val="F2F2F2"/>
-                    </a:solidFill>
-                  </a:tcPr>
-                </a:tc>
-                <a:tc>
-                  <a:txBody>
-                    <a:bodyPr wrap="square"/>
-                    <a:lstStyle/>
-                    <a:p>
-                      <a:pPr algn="ctr"/>
-                      <a:r>
-                        <a:rPr sz="1200" b="0">
-                          <a:solidFill>
-                            <a:srgbClr val="000000"/>
-                          </a:solidFill>
-                          <a:latin typeface="Calibri"/>
-                        </a:rPr>
-                        <a:t>2513.4</a:t>
-                      </a:r>
-                    </a:p>
-                  </a:txBody>
-                  <a:tcPr>
-                    <a:solidFill>
-                      <a:srgbClr val="F2F2F2"/>
-                    </a:solidFill>
-                  </a:tcPr>
-                </a:tc>
-                <a:tc>
-                  <a:txBody>
-                    <a:bodyPr wrap="square"/>
-                    <a:lstStyle/>
-                    <a:p>
-                      <a:pPr algn="ctr"/>
-                      <a:r>
-                        <a:rPr sz="1200" b="0">
-                          <a:solidFill>
-                            <a:srgbClr val="000000"/>
-                          </a:solidFill>
-                          <a:latin typeface="Calibri"/>
-                        </a:rPr>
-                        <a:t>9.93</a:t>
-                      </a:r>
-                    </a:p>
-                  </a:txBody>
-                  <a:tcPr>
-                    <a:solidFill>
-                      <a:srgbClr val="F2F2F2"/>
-                    </a:solidFill>
-                  </a:tcPr>
-                </a:tc>
-                <a:tc>
-                  <a:txBody>
-                    <a:bodyPr wrap="square"/>
-                    <a:lstStyle/>
-                    <a:p>
-                      <a:pPr algn="ctr"/>
-                      <a:r>
-                        <a:rPr sz="1200" b="0">
-                          <a:solidFill>
-                            <a:srgbClr val="000000"/>
-                          </a:solidFill>
-                          <a:latin typeface="Calibri"/>
-                        </a:rPr>
-                        <a:t>22.87</a:t>
-                      </a:r>
-                    </a:p>
-                  </a:txBody>
-                  <a:tcPr>
-                    <a:solidFill>
-                      <a:srgbClr val="F2F2F2"/>
-                    </a:solidFill>
-                  </a:tcPr>
-                </a:tc>
-                <a:tc>
-                  <a:txBody>
-                    <a:bodyPr wrap="square"/>
-                    <a:lstStyle/>
-                    <a:p>
-                      <a:pPr algn="ctr"/>
-                      <a:r>
-                        <a:rPr sz="1200" b="0">
-                          <a:solidFill>
-                            <a:srgbClr val="000000"/>
-                          </a:solidFill>
-                          <a:latin typeface="Calibri"/>
-                        </a:rPr>
-                        <a:t>15</a:t>
-                      </a:r>
-                    </a:p>
-                  </a:txBody>
-                  <a:tcPr>
-                    <a:solidFill>
-                      <a:srgbClr val="F2F2F2"/>
-                    </a:solidFill>
-                  </a:tcPr>
-                </a:tc>
-                <a:tc>
-                  <a:txBody>
-                    <a:bodyPr wrap="square"/>
-                    <a:lstStyle/>
-                    <a:p>
-                      <a:pPr algn="ctr"/>
-                      <a:r>
-                        <a:rPr sz="1200" b="0">
-                          <a:solidFill>
-                            <a:srgbClr val="000000"/>
-                          </a:solidFill>
-                          <a:latin typeface="Calibri"/>
-                        </a:rPr>
-                        <a:t>16.4</a:t>
-                      </a:r>
-                    </a:p>
-                  </a:txBody>
-                  <a:tcPr>
-                    <a:solidFill>
-                      <a:srgbClr val="F2F2F2"/>
-                    </a:solidFill>
-                  </a:tcPr>
-                </a:tc>
-              </a:tr>
-              <a:tr h="283333">
-                <a:tc>
-                  <a:txBody>
-                    <a:bodyPr wrap="square"/>
-                    <a:lstStyle/>
-                    <a:p>
-                      <a:pPr algn="l"/>
-                      <a:r>
-                        <a:rPr sz="1200" b="0">
-                          <a:solidFill>
-                            <a:srgbClr val="000000"/>
-                          </a:solidFill>
-                          <a:latin typeface="Calibri"/>
-                        </a:rPr>
-                        <a:t>2-029</a:t>
-                      </a:r>
-                    </a:p>
-                  </a:txBody>
-                  <a:tcPr>
-                    <a:solidFill>
-                      <a:srgbClr val="FFFFFF"/>
-                    </a:solidFill>
-                  </a:tcPr>
-                </a:tc>
-                <a:tc>
-                  <a:txBody>
-                    <a:bodyPr wrap="square"/>
-                    <a:lstStyle/>
-                    <a:p>
-                      <a:pPr algn="ctr"/>
-                      <a:r>
-                        <a:rPr sz="1200" b="0">
-                          <a:solidFill>
-                            <a:srgbClr val="000000"/>
-                          </a:solidFill>
-                          <a:latin typeface="Calibri"/>
-                        </a:rPr>
-                        <a:t>2515.1</a:t>
-                      </a:r>
-                    </a:p>
-                  </a:txBody>
-                  <a:tcPr>
-                    <a:solidFill>
-                      <a:srgbClr val="FFFFFF"/>
-                    </a:solidFill>
-                  </a:tcPr>
-                </a:tc>
-                <a:tc>
-                  <a:txBody>
-                    <a:bodyPr wrap="square"/>
-                    <a:lstStyle/>
-                    <a:p>
-                      <a:pPr algn="ctr"/>
-                      <a:r>
-                        <a:rPr sz="1200" b="0">
-                          <a:solidFill>
-                            <a:srgbClr val="000000"/>
-                          </a:solidFill>
-                          <a:latin typeface="Calibri"/>
-                        </a:rPr>
-                        <a:t>13.8</a:t>
-                      </a:r>
-                    </a:p>
-                  </a:txBody>
-                  <a:tcPr>
-                    <a:solidFill>
-                      <a:srgbClr val="FFFFFF"/>
-                    </a:solidFill>
-                  </a:tcPr>
-                </a:tc>
-                <a:tc>
-                  <a:txBody>
-                    <a:bodyPr wrap="square"/>
-                    <a:lstStyle/>
-                    <a:p>
-                      <a:pPr algn="ctr"/>
-                      <a:r>
-                        <a:rPr sz="1200" b="0">
-                          <a:solidFill>
-                            <a:srgbClr val="000000"/>
-                          </a:solidFill>
-                          <a:latin typeface="Calibri"/>
-                        </a:rPr>
-                        <a:t>18.1</a:t>
-                      </a:r>
-                    </a:p>
-                  </a:txBody>
-                  <a:tcPr>
-                    <a:solidFill>
-                      <a:srgbClr val="FFFFFF"/>
-                    </a:solidFill>
-                  </a:tcPr>
-                </a:tc>
-                <a:tc>
-                  <a:txBody>
-                    <a:bodyPr wrap="square"/>
-                    <a:lstStyle/>
-                    <a:p>
-                      <a:pPr algn="ctr"/>
-                      <a:r>
-                        <a:rPr sz="1200" b="0">
-                          <a:solidFill>
-                            <a:srgbClr val="000000"/>
-                          </a:solidFill>
-                          <a:latin typeface="Calibri"/>
-                        </a:rPr>
-                        <a:t>10</a:t>
-                      </a:r>
-                    </a:p>
-                  </a:txBody>
-                  <a:tcPr>
-                    <a:solidFill>
-                      <a:srgbClr val="FFFFFF"/>
-                    </a:solidFill>
-                  </a:tcPr>
-                </a:tc>
-                <a:tc>
-                  <a:txBody>
-                    <a:bodyPr wrap="square"/>
-                    <a:lstStyle/>
-                    <a:p>
-                      <a:pPr algn="ctr"/>
-                      <a:r>
-                        <a:rPr sz="1200" b="0">
-                          <a:solidFill>
-                            <a:srgbClr val="000000"/>
-                          </a:solidFill>
-                          <a:latin typeface="Calibri"/>
-                        </a:rPr>
-                        <a:t>10.5</a:t>
-                      </a:r>
-                    </a:p>
-                  </a:txBody>
-                  <a:tcPr>
-                    <a:solidFill>
-                      <a:srgbClr val="FFFFFF"/>
-                    </a:solidFill>
-                  </a:tcPr>
-                </a:tc>
-              </a:tr>
-              <a:tr h="283335">
-                <a:tc>
-                  <a:txBody>
-                    <a:bodyPr wrap="square"/>
-                    <a:lstStyle/>
-                    <a:p>
-                      <a:pPr algn="l"/>
-                      <a:r>
-                        <a:rPr sz="1200" b="0">
-                          <a:solidFill>
-                            <a:srgbClr val="000000"/>
-                          </a:solidFill>
-                          <a:latin typeface="Calibri"/>
-                        </a:rPr>
-                        <a:t>2-033</a:t>
-                      </a:r>
-                    </a:p>
-                  </a:txBody>
-                  <a:tcPr>
-                    <a:solidFill>
-                      <a:srgbClr val="F2F2F2"/>
-                    </a:solidFill>
-                  </a:tcPr>
-                </a:tc>
-                <a:tc>
-                  <a:txBody>
-                    <a:bodyPr wrap="square"/>
-                    <a:lstStyle/>
-                    <a:p>
-                      <a:pPr algn="ctr"/>
-                      <a:r>
-                        <a:rPr sz="1200" b="0">
-                          <a:solidFill>
-                            <a:srgbClr val="000000"/>
-                          </a:solidFill>
-                          <a:latin typeface="Calibri"/>
-                        </a:rPr>
-                        <a:t>2516.16</a:t>
-                      </a:r>
-                    </a:p>
-                  </a:txBody>
-                  <a:tcPr>
-                    <a:solidFill>
-                      <a:srgbClr val="F2F2F2"/>
-                    </a:solidFill>
-                  </a:tcPr>
-                </a:tc>
-                <a:tc>
-                  <a:txBody>
-                    <a:bodyPr wrap="square"/>
-                    <a:lstStyle/>
-                    <a:p>
-                      <a:pPr algn="ctr"/>
-                      <a:r>
-                        <a:rPr sz="1200" b="0">
-                          <a:solidFill>
-                            <a:srgbClr val="000000"/>
-                          </a:solidFill>
-                          <a:latin typeface="Calibri"/>
-                        </a:rPr>
-                        <a:t>21.6</a:t>
-                      </a:r>
-                    </a:p>
-                  </a:txBody>
-                  <a:tcPr>
-                    <a:solidFill>
-                      <a:srgbClr val="F2F2F2"/>
-                    </a:solidFill>
-                  </a:tcPr>
-                </a:tc>
-                <a:tc>
-                  <a:txBody>
-                    <a:bodyPr wrap="square"/>
-                    <a:lstStyle/>
-                    <a:p>
-                      <a:pPr algn="ctr"/>
-                      <a:r>
-                        <a:rPr sz="1200" b="0">
-                          <a:solidFill>
-                            <a:srgbClr val="000000"/>
-                          </a:solidFill>
-                          <a:latin typeface="Calibri"/>
-                        </a:rPr>
-                        <a:t>25.0</a:t>
-                      </a:r>
-                    </a:p>
-                  </a:txBody>
-                  <a:tcPr>
-                    <a:solidFill>
-                      <a:srgbClr val="F2F2F2"/>
-                    </a:solidFill>
-                  </a:tcPr>
-                </a:tc>
-                <a:tc>
-                  <a:txBody>
-                    <a:bodyPr wrap="square"/>
-                    <a:lstStyle/>
-                    <a:p>
-                      <a:pPr algn="ctr"/>
-                      <a:r>
-                        <a:rPr sz="1200" b="0">
-                          <a:solidFill>
-                            <a:srgbClr val="000000"/>
-                          </a:solidFill>
-                          <a:latin typeface="Calibri"/>
-                        </a:rPr>
-                        <a:t>5</a:t>
-                      </a:r>
-                    </a:p>
-                  </a:txBody>
-                  <a:tcPr>
-                    <a:solidFill>
-                      <a:srgbClr val="F2F2F2"/>
-                    </a:solidFill>
-                  </a:tcPr>
-                </a:tc>
-                <a:tc>
-                  <a:txBody>
-                    <a:bodyPr wrap="square"/>
-                    <a:lstStyle/>
-                    <a:p>
-                      <a:pPr algn="ctr"/>
-                      <a:r>
-                        <a:rPr sz="1200" b="0">
-                          <a:solidFill>
-                            <a:srgbClr val="000000"/>
-                          </a:solidFill>
-                          <a:latin typeface="Calibri"/>
-                        </a:rPr>
-                        <a:t>7.4</a:t>
-                      </a:r>
-                    </a:p>
-                  </a:txBody>
-                  <a:tcPr>
-                    <a:solidFill>
-                      <a:srgbClr val="F2F2F2"/>
-                    </a:solidFill>
-                  </a:tcPr>
-                </a:tc>
-              </a:tr>
-            </a:tbl>
-          </a:graphicData>
-        </a:graphic>
-      </p:graphicFrame>
-      <p:sp>
-        <p:nvSpPr>
-          <p:cNvPr id="7" name="TextBox 6"/>
-          <p:cNvSpPr txBox="1"/>
-          <p:nvPr/>
-        </p:nvSpPr>
-        <p:spPr>
-          <a:xfrm>
-            <a:off x="350000" y="2670000"/>
-            <a:ext cx="9993400" cy="3400000"/>
-          </a:xfrm>
-          <a:prstGeom prst="rect">
-            <a:avLst/>
-          </a:prstGeom>
-          <a:noFill/>
-        </p:spPr>
-        <p:txBody>
-          <a:bodyPr wrap="square" anchor="t">
-            <a:spAutoFit/>
-          </a:bodyPr>
-          <a:lstStyle/>
-          <a:p>
-            <a:pPr algn="l">
-              <a:buNone/>
-            </a:pPr>
-            <a:r>
-              <a:rPr lang="en-US" sz="1400" b="1" dirty="0">
-                <a:solidFill>
-                  <a:srgbClr val="002060"/>
-                </a:solidFill>
-              </a:rPr>
-              <a:t>Interpretation Methodology &amp; Key Findings</a:t>
-            </a:r>
-          </a:p>
-          <a:p>
-            <a:endParaRPr lang="en-US" sz="1100" dirty="0"/>
-          </a:p>
-          <a:p>
-            <a:pPr algn="l">
-              <a:buNone/>
-            </a:pPr>
-            <a:r>
-              <a:rPr lang="en-US" sz="1200" b="1" dirty="0">
-                <a:solidFill>
-                  <a:srgbClr val="002060"/>
-                </a:solidFill>
-              </a:rPr>
-              <a:t>Test Approach:</a:t>
-            </a:r>
-          </a:p>
-          <a:p>
-            <a:pPr algn="l" marL="457200" indent="-457200">
-              <a:buChar char="•"/>
-            </a:pPr>
-            <a:r>
-              <a:rPr lang="en-US" sz="1200" dirty="0">
-                <a:solidFill>
-                  <a:srgbClr val="000000"/>
-                </a:solidFill>
-              </a:rPr>
-              <a:t>Hybrid USS Kr gas-water drainage + single-speed imbibition centrifuge (water-decane)</a:t>
-            </a:r>
-          </a:p>
-          <a:p>
-            <a:pPr algn="l" marL="457200" indent="-457200">
-              <a:buChar char="•"/>
-            </a:pPr>
-            <a:r>
-              <a:rPr lang="en-US" sz="1200" dirty="0">
-                <a:solidFill>
-                  <a:srgbClr val="000000"/>
-                </a:solidFill>
-              </a:rPr>
-              <a:t>Drainage: yields krw curve (Swir to Sgr); Imbibition: yields krg curve</a:t>
-            </a:r>
-          </a:p>
-          <a:p>
-            <a:pPr algn="l" marL="457200" indent="-457200">
-              <a:buChar char="•"/>
-            </a:pPr>
-            <a:r>
-              <a:rPr lang="en-US" sz="1200" dirty="0">
-                <a:solidFill>
-                  <a:srgbClr val="000000"/>
-                </a:solidFill>
-              </a:rPr>
-              <a:t>No hysteresis assumed for wetting phase (water) between drainage and imbibition</a:t>
-            </a:r>
-          </a:p>
-          <a:p>
-            <a:endParaRPr lang="en-US" sz="1100" dirty="0"/>
-          </a:p>
-          <a:p>
-            <a:pPr algn="l">
-              <a:buNone/>
-            </a:pPr>
-            <a:r>
-              <a:rPr lang="en-US" sz="1200" b="1" dirty="0">
-                <a:solidFill>
-                  <a:srgbClr val="002060"/>
-                </a:solidFill>
-              </a:rPr>
-              <a:t>Numerical Interpretation:</a:t>
-            </a:r>
-          </a:p>
-          <a:p>
-            <a:pPr algn="l" marL="457200" indent="-457200">
-              <a:buChar char="•"/>
-            </a:pPr>
-            <a:r>
-              <a:rPr lang="en-US" sz="1200" dirty="0">
-                <a:solidFill>
-                  <a:srgbClr val="000000"/>
-                </a:solidFill>
-              </a:rPr>
-              <a:t>Sendra™ proprietary coreflood simulator (two-phase 1-D black oil model)</a:t>
-            </a:r>
-          </a:p>
-          <a:p>
-            <a:pPr algn="l" marL="457200" indent="-457200">
-              <a:buChar char="•"/>
-            </a:pPr>
-            <a:r>
-              <a:rPr lang="en-US" sz="1200" dirty="0">
-                <a:solidFill>
-                  <a:srgbClr val="000000"/>
-                </a:solidFill>
-              </a:rPr>
-              <a:t>Automated history matching routine applied to all 5 samples</a:t>
-            </a:r>
-          </a:p>
-          <a:p>
-            <a:pPr algn="l" marL="457200" indent="-457200">
-              <a:buChar char="•"/>
-            </a:pPr>
-            <a:r>
-              <a:rPr lang="en-US" sz="1200" dirty="0">
-                <a:solidFill>
-                  <a:srgbClr val="000000"/>
-                </a:solidFill>
-              </a:rPr>
-              <a:t>Prepared by Senergy International Sdn Bhd for MDC Oil &amp; Gas (SK320) Ltd, November 2015</a:t>
-            </a:r>
-          </a:p>
-          <a:p>
-            <a:endParaRPr lang="en-US" sz="1100" dirty="0"/>
-          </a:p>
-          <a:p>
-            <a:pPr algn="l">
-              <a:buNone/>
-            </a:pPr>
-            <a:r>
-              <a:rPr lang="en-US" sz="1200" b="1" dirty="0">
-                <a:solidFill>
-                  <a:srgbClr val="002060"/>
-                </a:solidFill>
-              </a:rPr>
-              <a:t>Extraction Performance:</a:t>
-            </a:r>
-          </a:p>
-          <a:p>
-            <a:pPr algn="l" marL="457200" indent="-457200">
-              <a:buChar char="–"/>
-            </a:pPr>
-            <a:r>
-              <a:rPr lang="en-US" sz="1200" dirty="0">
-                <a:solidFill>
-                  <a:srgbClr val="000000"/>
-                </a:solidFill>
-              </a:rPr>
-              <a:t>Most complex page: Page 15 — 37,705 s (10.5 hours for one page)</a:t>
-            </a:r>
-          </a:p>
-          <a:p>
-            <a:pPr algn="l" marL="457200" indent="-457200">
-              <a:buChar char="–"/>
-            </a:pPr>
-            <a:r>
-              <a:rPr lang="en-US" sz="1200" dirty="0">
-                <a:solidFill>
-                  <a:srgbClr val="000000"/>
-                </a:solidFill>
-              </a:rPr>
-              <a:t>Pages 22, 23, 35, 36, 43, 44 each exceeded 8,000 s — all contain dense tabular data</a:t>
-            </a:r>
-          </a:p>
-          <a:p>
-            <a:pPr algn="l" marL="457200" indent="-457200">
-              <a:buChar char="✓"/>
-            </a:pPr>
-            <a:r>
-              <a:rPr lang="en-US" sz="1200" dirty="0">
-                <a:solidFill>
-                  <a:srgbClr val="000000"/>
-                </a:solidFill>
-              </a:rPr>
-              <a:t>olmOCR ADE pipeline successfully extracted kr curves and history-matching tables from all 49 pages</a:t>
-            </a:r>
-          </a:p>
-        </p:txBody>
-      </p:sp>
-    </p:spTree>
-  </p:cSld>
-  <p:clrMapOvr>
-    <a:masterClrMapping/>
-  </p:clrMapOvr>
-</p:sld>
-</file>
-
-<file path=ppt/slides/slide27.xml><?xml version="1.0" encoding="utf-8"?>
+<file path=ppt/slides/slide25.xml><?xml version="1.0" encoding="utf-8"?>
 <p:sld xmlns:a="http://schemas.openxmlformats.org/drawingml/2006/main" xmlns:p="http://schemas.openxmlformats.org/presentationml/2006/main" xmlns:r="http://schemas.openxmlformats.org/officeDocument/2006/relationships">
   <p:cSld>
     <p:spTree>
@@ -22817,53 +20459,53 @@
                           </a:solidFill>
                           <a:latin typeface="Calibri"/>
                         </a:rPr>
-                        <a:t>4,087 s  (~68 min)</a:t>
-                      </a:r>
-                    </a:p>
-                  </a:txBody>
-                  <a:tcPr>
-                    <a:solidFill>
-                      <a:srgbClr val="F2F2F2"/>
-                    </a:solidFill>
-                  </a:tcPr>
-                </a:tc>
-                <a:tc>
-                  <a:txBody>
-                    <a:bodyPr wrap="square"/>
-                    <a:lstStyle/>
-                    <a:p>
-                      <a:pPr algn="ctr"/>
-                      <a:r>
-                        <a:rPr sz="1000" b="0">
-                          <a:solidFill>
-                            <a:srgbClr val="000000"/>
-                          </a:solidFill>
-                          <a:latin typeface="Calibri"/>
-                        </a:rPr>
-                        <a:t>91,809 s  (~25.5 hrs)</a:t>
-                      </a:r>
-                    </a:p>
-                  </a:txBody>
-                  <a:tcPr>
-                    <a:solidFill>
-                      <a:srgbClr val="F2F2F2"/>
-                    </a:solidFill>
-                  </a:tcPr>
-                </a:tc>
-                <a:tc>
-                  <a:txBody>
-                    <a:bodyPr wrap="square"/>
-                    <a:lstStyle/>
-                    <a:p>
-                      <a:pPr algn="ctr"/>
-                      <a:r>
-                        <a:rPr sz="1000" b="0">
-                          <a:solidFill>
-                            <a:srgbClr val="000000"/>
-                          </a:solidFill>
-                          <a:latin typeface="Calibri"/>
-                        </a:rPr>
-                        <a:t>176,782 s  (~49.1 hrs)</a:t>
+                        <a:t>68.1 min</a:t>
+                      </a:r>
+                    </a:p>
+                  </a:txBody>
+                  <a:tcPr>
+                    <a:solidFill>
+                      <a:srgbClr val="F2F2F2"/>
+                    </a:solidFill>
+                  </a:tcPr>
+                </a:tc>
+                <a:tc>
+                  <a:txBody>
+                    <a:bodyPr wrap="square"/>
+                    <a:lstStyle/>
+                    <a:p>
+                      <a:pPr algn="ctr"/>
+                      <a:r>
+                        <a:rPr sz="1000" b="0">
+                          <a:solidFill>
+                            <a:srgbClr val="000000"/>
+                          </a:solidFill>
+                          <a:latin typeface="Calibri"/>
+                        </a:rPr>
+                        <a:t>25.5 hrs</a:t>
+                      </a:r>
+                    </a:p>
+                  </a:txBody>
+                  <a:tcPr>
+                    <a:solidFill>
+                      <a:srgbClr val="F2F2F2"/>
+                    </a:solidFill>
+                  </a:tcPr>
+                </a:tc>
+                <a:tc>
+                  <a:txBody>
+                    <a:bodyPr wrap="square"/>
+                    <a:lstStyle/>
+                    <a:p>
+                      <a:pPr algn="ctr"/>
+                      <a:r>
+                        <a:rPr sz="1000" b="0">
+                          <a:solidFill>
+                            <a:srgbClr val="000000"/>
+                          </a:solidFill>
+                          <a:latin typeface="Calibri"/>
+                        </a:rPr>
+                        <a:t>49.1 hrs</a:t>
                       </a:r>
                     </a:p>
                   </a:txBody>
@@ -23099,53 +20741,53 @@
                           </a:solidFill>
                           <a:latin typeface="Calibri"/>
                         </a:rPr>
-                        <a:t>240 s  (4.0 min)</a:t>
-                      </a:r>
-                    </a:p>
-                  </a:txBody>
-                  <a:tcPr>
-                    <a:solidFill>
-                      <a:srgbClr val="FFFFFF"/>
-                    </a:solidFill>
-                  </a:tcPr>
-                </a:tc>
-                <a:tc>
-                  <a:txBody>
-                    <a:bodyPr wrap="square"/>
-                    <a:lstStyle/>
-                    <a:p>
-                      <a:pPr algn="ctr"/>
-                      <a:r>
-                        <a:rPr sz="1000" b="0">
-                          <a:solidFill>
-                            <a:srgbClr val="000000"/>
-                          </a:solidFill>
-                          <a:latin typeface="Calibri"/>
-                        </a:rPr>
-                        <a:t>2,416 s  (40 min)</a:t>
-                      </a:r>
-                    </a:p>
-                  </a:txBody>
-                  <a:tcPr>
-                    <a:solidFill>
-                      <a:srgbClr val="FFFFFF"/>
-                    </a:solidFill>
-                  </a:tcPr>
-                </a:tc>
-                <a:tc>
-                  <a:txBody>
-                    <a:bodyPr wrap="square"/>
-                    <a:lstStyle/>
-                    <a:p>
-                      <a:pPr algn="ctr"/>
-                      <a:r>
-                        <a:rPr sz="1000" b="0">
-                          <a:solidFill>
-                            <a:srgbClr val="000000"/>
-                          </a:solidFill>
-                          <a:latin typeface="Calibri"/>
-                        </a:rPr>
-                        <a:t>3,608 s  (60 min)</a:t>
+                        <a:t>4.0 min</a:t>
+                      </a:r>
+                    </a:p>
+                  </a:txBody>
+                  <a:tcPr>
+                    <a:solidFill>
+                      <a:srgbClr val="FFFFFF"/>
+                    </a:solidFill>
+                  </a:tcPr>
+                </a:tc>
+                <a:tc>
+                  <a:txBody>
+                    <a:bodyPr wrap="square"/>
+                    <a:lstStyle/>
+                    <a:p>
+                      <a:pPr algn="ctr"/>
+                      <a:r>
+                        <a:rPr sz="1000" b="0">
+                          <a:solidFill>
+                            <a:srgbClr val="000000"/>
+                          </a:solidFill>
+                          <a:latin typeface="Calibri"/>
+                        </a:rPr>
+                        <a:t>40.2 min</a:t>
+                      </a:r>
+                    </a:p>
+                  </a:txBody>
+                  <a:tcPr>
+                    <a:solidFill>
+                      <a:srgbClr val="FFFFFF"/>
+                    </a:solidFill>
+                  </a:tcPr>
+                </a:tc>
+                <a:tc>
+                  <a:txBody>
+                    <a:bodyPr wrap="square"/>
+                    <a:lstStyle/>
+                    <a:p>
+                      <a:pPr algn="ctr"/>
+                      <a:r>
+                        <a:rPr sz="1000" b="0">
+                          <a:solidFill>
+                            <a:srgbClr val="000000"/>
+                          </a:solidFill>
+                          <a:latin typeface="Calibri"/>
+                        </a:rPr>
+                        <a:t>60.1 min</a:t>
                       </a:r>
                     </a:p>
                   </a:txBody>
@@ -23193,53 +20835,53 @@
                           </a:solidFill>
                           <a:latin typeface="Calibri"/>
                         </a:rPr>
-                        <a:t>Page 1: 56.3 s</a:t>
-                      </a:r>
-                    </a:p>
-                  </a:txBody>
-                  <a:tcPr>
-                    <a:solidFill>
-                      <a:srgbClr val="F2F2F2"/>
-                    </a:solidFill>
-                  </a:tcPr>
-                </a:tc>
-                <a:tc>
-                  <a:txBody>
-                    <a:bodyPr wrap="square"/>
-                    <a:lstStyle/>
-                    <a:p>
-                      <a:pPr algn="ctr"/>
-                      <a:r>
-                        <a:rPr sz="1000" b="0">
-                          <a:solidFill>
-                            <a:srgbClr val="000000"/>
-                          </a:solidFill>
-                          <a:latin typeface="Calibri"/>
-                        </a:rPr>
-                        <a:t>Page 10: 98.0 s</a:t>
-                      </a:r>
-                    </a:p>
-                  </a:txBody>
-                  <a:tcPr>
-                    <a:solidFill>
-                      <a:srgbClr val="F2F2F2"/>
-                    </a:solidFill>
-                  </a:tcPr>
-                </a:tc>
-                <a:tc>
-                  <a:txBody>
-                    <a:bodyPr wrap="square"/>
-                    <a:lstStyle/>
-                    <a:p>
-                      <a:pPr algn="ctr"/>
-                      <a:r>
-                        <a:rPr sz="1000" b="0">
-                          <a:solidFill>
-                            <a:srgbClr val="000000"/>
-                          </a:solidFill>
-                          <a:latin typeface="Calibri"/>
-                        </a:rPr>
-                        <a:t>Page 2: 346.1 s</a:t>
+                        <a:t>Page 1: 0.9 min</a:t>
+                      </a:r>
+                    </a:p>
+                  </a:txBody>
+                  <a:tcPr>
+                    <a:solidFill>
+                      <a:srgbClr val="F2F2F2"/>
+                    </a:solidFill>
+                  </a:tcPr>
+                </a:tc>
+                <a:tc>
+                  <a:txBody>
+                    <a:bodyPr wrap="square"/>
+                    <a:lstStyle/>
+                    <a:p>
+                      <a:pPr algn="ctr"/>
+                      <a:r>
+                        <a:rPr sz="1000" b="0">
+                          <a:solidFill>
+                            <a:srgbClr val="000000"/>
+                          </a:solidFill>
+                          <a:latin typeface="Calibri"/>
+                        </a:rPr>
+                        <a:t>Page 10: 1.6 min</a:t>
+                      </a:r>
+                    </a:p>
+                  </a:txBody>
+                  <a:tcPr>
+                    <a:solidFill>
+                      <a:srgbClr val="F2F2F2"/>
+                    </a:solidFill>
+                  </a:tcPr>
+                </a:tc>
+                <a:tc>
+                  <a:txBody>
+                    <a:bodyPr wrap="square"/>
+                    <a:lstStyle/>
+                    <a:p>
+                      <a:pPr algn="ctr"/>
+                      <a:r>
+                        <a:rPr sz="1000" b="0">
+                          <a:solidFill>
+                            <a:srgbClr val="000000"/>
+                          </a:solidFill>
+                          <a:latin typeface="Calibri"/>
+                        </a:rPr>
+                        <a:t>Page 2: 5.8 min</a:t>
                       </a:r>
                     </a:p>
                   </a:txBody>
@@ -23287,53 +20929,53 @@
                           </a:solidFill>
                           <a:latin typeface="Calibri"/>
                         </a:rPr>
-                        <a:t>Page 8: 953 s (15.9 min)</a:t>
-                      </a:r>
-                    </a:p>
-                  </a:txBody>
-                  <a:tcPr>
-                    <a:solidFill>
-                      <a:srgbClr val="FFFFFF"/>
-                    </a:solidFill>
-                  </a:tcPr>
-                </a:tc>
-                <a:tc>
-                  <a:txBody>
-                    <a:bodyPr wrap="square"/>
-                    <a:lstStyle/>
-                    <a:p>
-                      <a:pPr algn="ctr"/>
-                      <a:r>
-                        <a:rPr sz="1000" b="0">
-                          <a:solidFill>
-                            <a:srgbClr val="000000"/>
-                          </a:solidFill>
-                          <a:latin typeface="Calibri"/>
-                        </a:rPr>
-                        <a:t>Page 21: 12,061 s (3.3 hrs)</a:t>
-                      </a:r>
-                    </a:p>
-                  </a:txBody>
-                  <a:tcPr>
-                    <a:solidFill>
-                      <a:srgbClr val="FFFFFF"/>
-                    </a:solidFill>
-                  </a:tcPr>
-                </a:tc>
-                <a:tc>
-                  <a:txBody>
-                    <a:bodyPr wrap="square"/>
-                    <a:lstStyle/>
-                    <a:p>
-                      <a:pPr algn="ctr"/>
-                      <a:r>
-                        <a:rPr sz="1000" b="0">
-                          <a:solidFill>
-                            <a:srgbClr val="000000"/>
-                          </a:solidFill>
-                          <a:latin typeface="Calibri"/>
-                        </a:rPr>
-                        <a:t>Page 15: 37,705 s (10.5 hrs!)</a:t>
+                        <a:t>Page 8: 15.9 min</a:t>
+                      </a:r>
+                    </a:p>
+                  </a:txBody>
+                  <a:tcPr>
+                    <a:solidFill>
+                      <a:srgbClr val="FFFFFF"/>
+                    </a:solidFill>
+                  </a:tcPr>
+                </a:tc>
+                <a:tc>
+                  <a:txBody>
+                    <a:bodyPr wrap="square"/>
+                    <a:lstStyle/>
+                    <a:p>
+                      <a:pPr algn="ctr"/>
+                      <a:r>
+                        <a:rPr sz="1000" b="0">
+                          <a:solidFill>
+                            <a:srgbClr val="000000"/>
+                          </a:solidFill>
+                          <a:latin typeface="Calibri"/>
+                        </a:rPr>
+                        <a:t>Page 21: 3.3 hrs</a:t>
+                      </a:r>
+                    </a:p>
+                  </a:txBody>
+                  <a:tcPr>
+                    <a:solidFill>
+                      <a:srgbClr val="FFFFFF"/>
+                    </a:solidFill>
+                  </a:tcPr>
+                </a:tc>
+                <a:tc>
+                  <a:txBody>
+                    <a:bodyPr wrap="square"/>
+                    <a:lstStyle/>
+                    <a:p>
+                      <a:pPr algn="ctr"/>
+                      <a:r>
+                        <a:rPr sz="1000" b="0">
+                          <a:solidFill>
+                            <a:srgbClr val="000000"/>
+                          </a:solidFill>
+                          <a:latin typeface="Calibri"/>
+                        </a:rPr>
+                        <a:t>Page 15: 10.5 hrs</a:t>
                       </a:r>
                     </a:p>
                   </a:txBody>
@@ -23358,7 +21000,7 @@
                           </a:solidFill>
                           <a:latin typeface="Calibri"/>
                         </a:rPr>
-                        <a:t>Complex pages (&gt;5000s)</a:t>
+                        <a:t>Pages &gt; 1 hr</a:t>
                       </a:r>
                     </a:p>
                   </a:txBody>
@@ -23404,30 +21046,30 @@
                           </a:solidFill>
                           <a:latin typeface="Calibri"/>
                         </a:rPr>
-                        <a:t>Pages 15, 17, 19, 21</a:t>
-                      </a:r>
-                    </a:p>
-                  </a:txBody>
-                  <a:tcPr>
-                    <a:solidFill>
-                      <a:srgbClr val="F2F2F2"/>
-                    </a:solidFill>
-                  </a:tcPr>
-                </a:tc>
-                <a:tc>
-                  <a:txBody>
-                    <a:bodyPr wrap="square"/>
-                    <a:lstStyle/>
-                    <a:p>
-                      <a:pPr algn="ctr"/>
-                      <a:r>
-                        <a:rPr sz="1000" b="0">
-                          <a:solidFill>
-                            <a:srgbClr val="000000"/>
-                          </a:solidFill>
-                          <a:latin typeface="Calibri"/>
-                        </a:rPr>
-                        <a:t>Pages 15, 22, 23, 29, 30, 35, 36, 43, 44</a:t>
+                        <a:t>Pages 15, 17, 19, 21  (4 pages)</a:t>
+                      </a:r>
+                    </a:p>
+                  </a:txBody>
+                  <a:tcPr>
+                    <a:solidFill>
+                      <a:srgbClr val="F2F2F2"/>
+                    </a:solidFill>
+                  </a:tcPr>
+                </a:tc>
+                <a:tc>
+                  <a:txBody>
+                    <a:bodyPr wrap="square"/>
+                    <a:lstStyle/>
+                    <a:p>
+                      <a:pPr algn="ctr"/>
+                      <a:r>
+                        <a:rPr sz="1000" b="0">
+                          <a:solidFill>
+                            <a:srgbClr val="000000"/>
+                          </a:solidFill>
+                          <a:latin typeface="Calibri"/>
+                        </a:rPr>
+                        <a:t>Pages 15, 16, 22–23, 35–36, 43–44  (8 pages)</a:t>
                       </a:r>
                     </a:p>
                   </a:txBody>
@@ -23498,7 +21140,7 @@
                           </a:solidFill>
                           <a:latin typeface="Calibri"/>
                         </a:rPr>
-                        <a:t>5+ data tables</a:t>
+                        <a:t>5+ SCAL data tables</a:t>
                       </a:r>
                     </a:p>
                   </a:txBody>
@@ -23755,7 +21397,7 @@
                   <a:srgbClr val="595959"/>
                 </a:solidFill>
               </a:rPr>
-              <a:t>Observation: Extraction time scales non-linearly with document complexity (dense tables, multi-panel graphs). Simple text pages: ~300–600 s. Dense SCAL data tables: 1,000–12,000 s. Complex kr plot pages: up to 37,705 s.</a:t>
+              <a:t>Observation: Extraction time scales non-linearly with complexity. Simple text pages: ~5–20 min.  Dense SCAL data tables: 20–80 min.  Complex multi-panel graph pages: up to 10.5 hrs.</a:t>
             </a:r>
           </a:p>
         </p:txBody>

</xml_diff>